<commit_message>
Part II: add robustness checks and reword the AI-alarm claim
maintenance_checks.py tests the strategy result against cross-talk
(set 1 B3's early AI alarm is its own signal), 27 threshold settings
(physics OR AI catches 4/4 in all), leave-one-test-out, and false-alarm
cost. The AI alarm is reframed as insurance against a mis-set physics
threshold; the deck gains a robustness slide.

Co-Authored-By: Claude Opus 5.5 <noreply@anthropic.com>
</commit_message>
<xml_diff>
--- a/predictive_maintenance_part2.pptx
+++ b/predictive_maintenance_part2.pptx
@@ -14,6 +14,7 @@
     <p:sldId id="275" r:id="rId14"/>
     <p:sldId id="276" r:id="rId8"/>
     <p:sldId id="277" r:id="rId7"/>
+    <p:sldId id="278" r:id="rId6"/>
     <p:sldId id="269" r:id="rId15"/>
   </p:sldIdLst>
   <p:notesMasterIdLst>
@@ -2226,6 +2227,76 @@
           <a:lstStyle/>
           <a:p>
             <a:r>
+              <a:t>We also tried the textbook predictive-maintenance approach: predict the remaining useful life in hours, then act when it is short. Two attempts, both negative, and we think both are findings. First, gradient boosting with a calibrated safety margin. The honest margin came out at 17 to 59 hours, as wide as the lead time, so it fires right at the alarm and never beats simply acting on the alarm. The reason is in the data: after the alarm, the four bearings lasted 12, 53, 70 and 97 hours, too spread for three training examples. Second, Chronos-2, a large pretrained time-series model: it forecast the vibration levelling off instead of accelerating, and its error was more than twice that of gradient boosting.</a:t>
+            </a:r>
+          </a:p>
+        </p:txBody>
+      </p:sp>
+      <p:sp>
+        <p:nvSpPr>
+          <p:cNvPr id="4" name="Slide Number Placeholder 3"/>
+          <p:cNvSpPr>
+            <a:spLocks noGrp="1"/>
+          </p:cNvSpPr>
+          <p:nvPr>
+            <p:ph type="sldNum" idx="5" sz="quarter"/>
+          </p:nvPr>
+        </p:nvSpPr>
+        <p:spPr/>
+      </p:sp>
+    </p:spTree>
+  </p:cSld>
+  <p:clrMapOvr>
+    <a:masterClrMapping/>
+  </p:clrMapOvr>
+</p:notes>
+</file>
+
+<file path=ppt/notesSlides/notesSlide11.xml><?xml version="1.0" encoding="utf-8"?>
+<p:notes xmlns:a="http://schemas.openxmlformats.org/drawingml/2006/main" xmlns:p="http://schemas.openxmlformats.org/presentationml/2006/main" xmlns:r="http://schemas.openxmlformats.org/officeDocument/2006/relationships">
+  <p:cSld>
+    <p:spTree>
+      <p:nvGrpSpPr>
+        <p:cNvPr id="1" name=""/>
+        <p:cNvGrpSpPr/>
+        <p:nvPr/>
+      </p:nvGrpSpPr>
+      <p:grpSpPr>
+        <a:xfrm>
+          <a:off x="0" y="0"/>
+          <a:ext cx="0" cy="0"/>
+          <a:chOff x="0" y="0"/>
+          <a:chExt cx="0" cy="0"/>
+        </a:xfrm>
+      </p:grpSpPr>
+      <p:sp>
+        <p:nvSpPr>
+          <p:cNvPr id="2" name="Slide Image Placeholder 1"/>
+          <p:cNvSpPr>
+            <a:spLocks noGrp="1"/>
+          </p:cNvSpPr>
+          <p:nvPr>
+            <p:ph type="sldImg" idx="2"/>
+          </p:nvPr>
+        </p:nvSpPr>
+        <p:spPr/>
+      </p:sp>
+      <p:sp>
+        <p:nvSpPr>
+          <p:cNvPr id="3" name="Notes Placeholder 2"/>
+          <p:cNvSpPr>
+            <a:spLocks noGrp="1"/>
+          </p:cNvSpPr>
+          <p:nvPr>
+            <p:ph type="body" idx="3" sz="quarter"/>
+          </p:nvPr>
+        </p:nvSpPr>
+        <p:spPr/>
+        <p:txBody>
+          <a:bodyPr/>
+          <a:lstStyle/>
+          <a:p>
+            <a:r>
               <a:t>To be clear about our contribution: Part II builds no new detector; the two alarms come from Part I. What it adds is the decision analysis: a cost model that replays reactive, preventive and condition-based maintenance on real run-to-failure data; the finding that the physics and AI alarms complement each other; the operating envelope, breakdown cost above twice a repair and replacement within two days; and two documented negative results. The limits: only four failures, both detectors' thresholds were set on these same bearings, and the cost numbers are assumptions, which is why we show them as ranges.</a:t>
             </a:r>
           </a:p>
@@ -2452,7 +2523,7 @@
           <a:lstStyle/>
           <a:p>
             <a:r>
-              <a:t>Part I gave us two condition monitors. The physics alarm compares each bearing's vibration energy with its neighbours. The AI alarm is an autoencoder trained only on healthy data: it flags a bearing whose vibration it cannot reconstruct. Neither uses fault labels. The bars show how many hours before failure each one warns. The AI warns about the inner-race fault 71 hours ahead, where physics gives only 12. Physics catches set 3 bearing 3, which the AI misses completely. And the AI never alarmed on a healthy bearing; physics did twice. So the two are complementary: use either one's alarm.</a:t>
+              <a:t>Part I gave us two condition monitors. The physics alarm compares each bearing's vibration energy with its neighbours. The AI alarm is an autoencoder trained only on healthy data: it flags a bearing whose vibration it cannot reconstruct. Neither uses fault labels. The bars show how many hours before failure each one warns. The AI warns about the inner-race fault 71 hours ahead, where physics gives only 12. Physics catches set 3 bearing 3, which the AI misses completely. And the AI never alarmed on a healthy bearing; physics did twice. We checked that the early AI alarm on set 1 bearing 3 is its own impact signal, kurtosis and peaks, and not its failing neighbour bearing 4 heard through the housing. So the two are complementary: use either one's alarm.</a:t>
             </a:r>
           </a:p>
         </p:txBody>
@@ -2732,7 +2803,7 @@
           <a:lstStyle/>
           <a:p>
             <a:r>
-              <a:t>How fast does the crew have to act after the alarm? With up to 8 hours, the physics alarm alone catches all four. Between 12 and 48 hours, physics and AI each catch three, and only their combination catches all four: this is where the AI adds value. At 72 hours everything collapses to one of four, because the alarms come 53 to 119 hours before failure. So condition monitoring on these bearings works if replacement happens within about two days of the alarm.</a:t>
+              <a:t>How fast does the crew have to act after the alarm? With up to 8 hours, the physics alarm alone catches all four. Between 12 and 48 hours, physics and AI each catch three, and only their combination catches all four: this is where the AI adds value. At 72 hours everything collapses to one of four, because the alarms come 53 to 119 hours before failure. So condition monitoring on these bearings works if replacement happens within about two days of the alarm. Note this is at our default thresholds; the next slide shows what changes when we move them.</a:t>
             </a:r>
           </a:p>
         </p:txBody>
@@ -2802,7 +2873,7 @@
           <a:lstStyle/>
           <a:p>
             <a:r>
-              <a:t>We also tried the textbook predictive-maintenance approach: predict the remaining useful life in hours, then act when it is short. Two attempts, both negative, and we think both are findings. First, gradient boosting with a calibrated safety margin. The honest margin came out at 17 to 59 hours, as wide as the lead time, so it fires right at the alarm and never beats simply acting on the alarm. The reason is in the data: after the alarm, the four bearings lasted 12, 53, 70 and 97 hours, too spread for three training examples. Second, Chronos-2, a large pretrained time-series model: it forecast the vibration levelling off instead of accelerating, and its error was more than twice that of gradient boosting.</a:t>
+              <a:t>We tested the result against the obvious objections. First, the thresholds were tuned on these same bearings, so we moved all three of them: 27 combinations. Acting on either alarm catches all four failures in every one, at 0.81 to 1.08 per thousand hours. Physics alone catches all four in only 9 of 27. So the AI alarm is insurance: a factory cannot tune its threshold on failures it has not seen. Second, holding out one test at a time, condition-based maintenance always beats reactive and preventive, but which alarm rule is cheapest changes: without set 3, the AI alone wins. Third, if a false alarm costs about four times a planned job or more, the AI alone, with no false alarms, is cheapest. So we claim robustness, not a single winner.</a:t>
             </a:r>
           </a:p>
         </p:txBody>
@@ -3984,7 +4055,7 @@
           <a:lstStyle/>
           <a:p>
             <a:r>
-              <a:t>What Part II adds, and its limits</a:t>
+              <a:t>What didn’t work: predicting the hours left</a:t>
             </a:r>
           </a:p>
         </p:txBody>
@@ -4036,20 +4107,22 @@
       </p:sp>
       <p:sp>
         <p:nvSpPr>
-          <p:cNvPr id="26" name="badge 1"/>
+          <p:cNvPr id="26" name="negative Calibrated RUL bound"/>
           <p:cNvSpPr/>
           <p:nvPr/>
         </p:nvSpPr>
         <p:spPr>
           <a:xfrm>
-            <a:off x="548640" y="1463040"/>
-            <a:ext cx="685800" cy="685800"/>
-          </a:xfrm>
-          <a:prstGeom prst="ellipse">
-            <a:avLst/>
+            <a:off x="548640" y="1371600"/>
+            <a:ext cx="5394960" cy="4023360"/>
+          </a:xfrm>
+          <a:prstGeom prst="roundRect">
+            <a:avLst>
+              <a:gd name="adj" fmla="val 8000"/>
+            </a:avLst>
           </a:prstGeom>
           <a:solidFill>
-            <a:srgbClr val="F26B4F"/>
+            <a:schemeClr val="bg2"/>
           </a:solidFill>
           <a:ln>
             <a:noFill/>
@@ -4071,18 +4144,10 @@
           </a:fontRef>
         </p:style>
         <p:txBody>
-          <a:bodyPr rtlCol="0" anchor="ctr" lIns="0" rIns="0" tIns="0" bIns="0"/>
+          <a:bodyPr rtlCol="0" anchor="ctr"/>
           <a:lstStyle/>
           <a:p>
             <a:pPr algn="ctr"/>
-            <a:r>
-              <a:rPr sz="2000" b="1">
-                <a:solidFill>
-                  <a:srgbClr val="FFFFFF"/>
-                </a:solidFill>
-              </a:rPr>
-              <a:t>1</a:t>
-            </a:r>
           </a:p>
         </p:txBody>
       </p:sp>
@@ -4094,8 +4159,8 @@
         </p:nvSpPr>
         <p:spPr>
           <a:xfrm>
-            <a:off x="1463040" y="1371600"/>
-            <a:ext cx="5577840" cy="411480"/>
+            <a:off x="868680" y="1600200"/>
+            <a:ext cx="4754880" cy="457200"/>
           </a:xfrm>
           <a:prstGeom prst="rect">
             <a:avLst/>
@@ -4114,12 +4179,12 @@
               </a:spcAft>
             </a:pPr>
             <a:r>
-              <a:rPr sz="2000" b="1">
+              <a:rPr sz="2200" b="1">
                 <a:solidFill>
                   <a:srgbClr val="12262B"/>
                 </a:solidFill>
               </a:rPr>
-              <a:t>Cost model</a:t>
+              <a:t>Calibrated RUL bound</a:t>
             </a:r>
           </a:p>
         </p:txBody>
@@ -4132,8 +4197,8 @@
         </p:nvSpPr>
         <p:spPr>
           <a:xfrm>
-            <a:off x="1463040" y="1810512"/>
-            <a:ext cx="5577840" cy="640080"/>
+            <a:off x="868680" y="2194560"/>
+            <a:ext cx="4754880" cy="822960"/>
           </a:xfrm>
           <a:prstGeom prst="rect">
             <a:avLst/>
@@ -4152,32 +4217,125 @@
               </a:spcAft>
             </a:pPr>
             <a:r>
+              <a:rPr sz="4400" b="1">
+                <a:solidFill>
+                  <a:srgbClr val="D64545"/>
+                </a:solidFill>
+              </a:rPr>
+              <a:t>17-59 h</a:t>
+            </a:r>
+          </a:p>
+        </p:txBody>
+      </p:sp>
+      <p:sp>
+        <p:nvSpPr>
+          <p:cNvPr id="29" name="TextBox 28"/>
+          <p:cNvSpPr txBox="1"/>
+          <p:nvPr/>
+        </p:nvSpPr>
+        <p:spPr>
+          <a:xfrm>
+            <a:off x="868680" y="3017520"/>
+            <a:ext cx="4754880" cy="457200"/>
+          </a:xfrm>
+          <a:prstGeom prst="rect">
+            <a:avLst/>
+          </a:prstGeom>
+          <a:noFill/>
+        </p:spPr>
+        <p:txBody>
+          <a:bodyPr wrap="square" anchor="t" lIns="0" rIns="0" tIns="0" bIns="0">
+            <a:spAutoFit/>
+          </a:bodyPr>
+          <a:lstStyle/>
+          <a:p>
+            <a:pPr algn="l">
+              <a:spcAft>
+                <a:spcPts val="600"/>
+              </a:spcAft>
+            </a:pPr>
+            <a:r>
               <a:rPr sz="1500" b="0">
                 <a:solidFill>
                   <a:srgbClr val="5E6E70"/>
                 </a:solidFill>
               </a:rPr>
-              <a:t>Reactive, preventive and condition-based replayed on real run-to-failure data</a:t>
-            </a:r>
-          </a:p>
-        </p:txBody>
-      </p:sp>
-      <p:sp>
-        <p:nvSpPr>
-          <p:cNvPr id="29" name="badge 2"/>
+              <a:t>safety margin, as wide as the lead time</a:t>
+            </a:r>
+          </a:p>
+        </p:txBody>
+      </p:sp>
+      <p:sp>
+        <p:nvSpPr>
+          <p:cNvPr id="30" name="TextBox 29"/>
+          <p:cNvSpPr txBox="1"/>
+          <p:nvPr/>
+        </p:nvSpPr>
+        <p:spPr>
+          <a:xfrm>
+            <a:off x="868680" y="3749039"/>
+            <a:ext cx="4754880" cy="2194560"/>
+          </a:xfrm>
+          <a:prstGeom prst="rect">
+            <a:avLst/>
+          </a:prstGeom>
+          <a:noFill/>
+        </p:spPr>
+        <p:txBody>
+          <a:bodyPr wrap="square" anchor="t" lIns="0" rIns="0" tIns="0" bIns="0">
+            <a:spAutoFit/>
+          </a:bodyPr>
+          <a:lstStyle/>
+          <a:p>
+            <a:pPr algn="l">
+              <a:spcAft>
+                <a:spcPts val="1000"/>
+              </a:spcAft>
+            </a:pPr>
+            <a:r>
+              <a:rPr sz="1600" b="0">
+                <a:solidFill>
+                  <a:srgbClr val="12262B"/>
+                </a:solidFill>
+              </a:rPr>
+              <a:t>Never beats “act at the alarm” for lead times 4-48 h</a:t>
+            </a:r>
+          </a:p>
+          <a:p>
+            <a:pPr algn="l">
+              <a:spcAft>
+                <a:spcPts val="1000"/>
+              </a:spcAft>
+            </a:pPr>
+            <a:r>
+              <a:rPr sz="1600" b="0">
+                <a:solidFill>
+                  <a:srgbClr val="12262B"/>
+                </a:solidFill>
+              </a:rPr>
+              <a:t>After the alarm the bearings lasted 12, 53, 70, 97 h: too spread to learn from 3 examples</a:t>
+            </a:r>
+          </a:p>
+        </p:txBody>
+      </p:sp>
+      <p:sp>
+        <p:nvSpPr>
+          <p:cNvPr id="31" name="negative Foundation model (Chronos-2)"/>
           <p:cNvSpPr/>
           <p:nvPr/>
         </p:nvSpPr>
         <p:spPr>
           <a:xfrm>
-            <a:off x="548640" y="2651760"/>
-            <a:ext cx="685800" cy="685800"/>
-          </a:xfrm>
-          <a:prstGeom prst="ellipse">
-            <a:avLst/>
+            <a:off x="6217920" y="1371600"/>
+            <a:ext cx="5394960" cy="4023360"/>
+          </a:xfrm>
+          <a:prstGeom prst="roundRect">
+            <a:avLst>
+              <a:gd name="adj" fmla="val 8000"/>
+            </a:avLst>
           </a:prstGeom>
           <a:solidFill>
-            <a:srgbClr val="F26B4F"/>
+            <a:schemeClr val="bg2"/>
           </a:solidFill>
           <a:ln>
             <a:noFill/>
@@ -4199,31 +4357,23 @@
           </a:fontRef>
         </p:style>
         <p:txBody>
-          <a:bodyPr rtlCol="0" anchor="ctr" lIns="0" rIns="0" tIns="0" bIns="0"/>
+          <a:bodyPr rtlCol="0" anchor="ctr"/>
           <a:lstStyle/>
           <a:p>
             <a:pPr algn="ctr"/>
-            <a:r>
-              <a:rPr sz="2000" b="1">
-                <a:solidFill>
-                  <a:srgbClr val="FFFFFF"/>
-                </a:solidFill>
-              </a:rPr>
-              <a:t>2</a:t>
-            </a:r>
-          </a:p>
-        </p:txBody>
-      </p:sp>
-      <p:sp>
-        <p:nvSpPr>
-          <p:cNvPr id="30" name="TextBox 29"/>
+          </a:p>
+        </p:txBody>
+      </p:sp>
+      <p:sp>
+        <p:nvSpPr>
+          <p:cNvPr id="32" name="TextBox 31"/>
           <p:cNvSpPr txBox="1"/>
           <p:nvPr/>
         </p:nvSpPr>
         <p:spPr>
           <a:xfrm>
-            <a:off x="1463040" y="2560320"/>
-            <a:ext cx="5577840" cy="411480"/>
+            <a:off x="6537959" y="1600200"/>
+            <a:ext cx="4754880" cy="457200"/>
           </a:xfrm>
           <a:prstGeom prst="rect">
             <a:avLst/>
@@ -4242,26 +4392,26 @@
               </a:spcAft>
             </a:pPr>
             <a:r>
-              <a:rPr sz="2000" b="1">
+              <a:rPr sz="2200" b="1">
                 <a:solidFill>
                   <a:srgbClr val="12262B"/>
                 </a:solidFill>
               </a:rPr>
-              <a:t>Complementary alarms</a:t>
-            </a:r>
-          </a:p>
-        </p:txBody>
-      </p:sp>
-      <p:sp>
-        <p:nvSpPr>
-          <p:cNvPr id="31" name="TextBox 30"/>
+              <a:t>Foundation model (Chronos-2)</a:t>
+            </a:r>
+          </a:p>
+        </p:txBody>
+      </p:sp>
+      <p:sp>
+        <p:nvSpPr>
+          <p:cNvPr id="33" name="TextBox 32"/>
           <p:cNvSpPr txBox="1"/>
           <p:nvPr/>
         </p:nvSpPr>
         <p:spPr>
           <a:xfrm>
-            <a:off x="1463040" y="2999232"/>
-            <a:ext cx="5577840" cy="640080"/>
+            <a:off x="6537959" y="2194560"/>
+            <a:ext cx="4754880" cy="822960"/>
           </a:xfrm>
           <a:prstGeom prst="rect">
             <a:avLst/>
@@ -4280,25 +4430,200 @@
               </a:spcAft>
             </a:pPr>
             <a:r>
+              <a:rPr sz="4400" b="1">
+                <a:solidFill>
+                  <a:srgbClr val="D64545"/>
+                </a:solidFill>
+              </a:rPr>
+              <a:t>56 vs 25 h</a:t>
+            </a:r>
+          </a:p>
+        </p:txBody>
+      </p:sp>
+      <p:sp>
+        <p:nvSpPr>
+          <p:cNvPr id="34" name="TextBox 33"/>
+          <p:cNvSpPr txBox="1"/>
+          <p:nvPr/>
+        </p:nvSpPr>
+        <p:spPr>
+          <a:xfrm>
+            <a:off x="6537959" y="3017520"/>
+            <a:ext cx="4754880" cy="457200"/>
+          </a:xfrm>
+          <a:prstGeom prst="rect">
+            <a:avLst/>
+          </a:prstGeom>
+          <a:noFill/>
+        </p:spPr>
+        <p:txBody>
+          <a:bodyPr wrap="square" anchor="t" lIns="0" rIns="0" tIns="0" bIns="0">
+            <a:spAutoFit/>
+          </a:bodyPr>
+          <a:lstStyle/>
+          <a:p>
+            <a:pPr algn="l">
+              <a:spcAft>
+                <a:spcPts val="600"/>
+              </a:spcAft>
+            </a:pPr>
+            <a:r>
               <a:rPr sz="1500" b="0">
                 <a:solidFill>
                   <a:srgbClr val="5E6E70"/>
                 </a:solidFill>
               </a:rPr>
-              <a:t>Physics and AI miss different failures; either alarm catches all 4</a:t>
-            </a:r>
-          </a:p>
-        </p:txBody>
-      </p:sp>
-      <p:sp>
-        <p:nvSpPr>
-          <p:cNvPr id="32" name="badge 3"/>
+              <a:t>RUL error vs gradient boosting (set 2 B1)</a:t>
+            </a:r>
+          </a:p>
+        </p:txBody>
+      </p:sp>
+      <p:sp>
+        <p:nvSpPr>
+          <p:cNvPr id="35" name="TextBox 34"/>
+          <p:cNvSpPr txBox="1"/>
+          <p:nvPr/>
+        </p:nvSpPr>
+        <p:spPr>
+          <a:xfrm>
+            <a:off x="6537959" y="3749039"/>
+            <a:ext cx="4754880" cy="2194560"/>
+          </a:xfrm>
+          <a:prstGeom prst="rect">
+            <a:avLst/>
+          </a:prstGeom>
+          <a:noFill/>
+        </p:spPr>
+        <p:txBody>
+          <a:bodyPr wrap="square" anchor="t" lIns="0" rIns="0" tIns="0" bIns="0">
+            <a:spAutoFit/>
+          </a:bodyPr>
+          <a:lstStyle/>
+          <a:p>
+            <a:pPr algn="l">
+              <a:spcAft>
+                <a:spcPts val="1000"/>
+              </a:spcAft>
+            </a:pPr>
+            <a:r>
+              <a:rPr sz="1600" b="0">
+                <a:solidFill>
+                  <a:srgbClr val="12262B"/>
+                </a:solidFill>
+              </a:rPr>
+              <a:t>Forecast the vibration levelling off; it actually accelerated</a:t>
+            </a:r>
+          </a:p>
+          <a:p>
+            <a:pPr algn="l">
+              <a:spcAft>
+                <a:spcPts val="1000"/>
+              </a:spcAft>
+            </a:pPr>
+            <a:r>
+              <a:rPr sz="1600" b="0">
+                <a:solidFill>
+                  <a:srgbClr val="12262B"/>
+                </a:solidFill>
+              </a:rPr>
+              <a:t>Pretrained forecasters continue patterns; failure breaks the pattern</a:t>
+            </a:r>
+          </a:p>
+        </p:txBody>
+      </p:sp>
+    </p:spTree>
+  </p:cSld>
+  <p:clrMapOvr>
+    <a:masterClrMapping/>
+  </p:clrMapOvr>
+</p:sld>
+</file>
+
+<file path=ppt/slides/slide11.xml><?xml version="1.0" encoding="utf-8"?>
+<p:sld xmlns:a="http://schemas.openxmlformats.org/drawingml/2006/main" xmlns:p="http://schemas.openxmlformats.org/presentationml/2006/main" xmlns:r="http://schemas.openxmlformats.org/officeDocument/2006/relationships">
+  <p:cSld>
+    <p:spTree>
+      <p:nvGrpSpPr>
+        <p:cNvPr id="1" name=""/>
+        <p:cNvGrpSpPr/>
+        <p:nvPr/>
+      </p:nvGrpSpPr>
+      <p:grpSpPr/>
+      <p:sp>
+        <p:nvSpPr>
+          <p:cNvPr id="2" name="Title 1"/>
+          <p:cNvSpPr>
+            <a:spLocks noGrp="1"/>
+          </p:cNvSpPr>
+          <p:nvPr>
+            <p:ph type="title" idx="100"/>
+          </p:nvPr>
+        </p:nvSpPr>
+        <p:spPr/>
+        <p:txBody>
+          <a:bodyPr/>
+          <a:lstStyle/>
+          <a:p>
+            <a:r>
+              <a:t>What Part II adds, and its limits</a:t>
+            </a:r>
+          </a:p>
+        </p:txBody>
+      </p:sp>
+      <p:sp>
+        <p:nvSpPr>
+          <p:cNvPr id="25" name="Slide Number Placeholder 0"/>
+          <p:cNvSpPr>
+            <a:spLocks noGrp="1"/>
+          </p:cNvSpPr>
+          <p:nvPr>
+            <p:ph type="sldNum" sz="quarter" idx="4294967295"/>
+          </p:nvPr>
+        </p:nvSpPr>
+        <p:spPr>
+          <a:xfrm>
+            <a:off x="11155680" y="6400800"/>
+            <a:ext cx="457200" cy="274320"/>
+          </a:xfrm>
+          <a:prstGeom prst="rect">
+            <a:avLst/>
+          </a:prstGeom>
+          <a:extLst>
+            <a:ext uri="{C572A759-6A51-4108-AA02-DFA0A04FC94B}">
+              <ma14:wrappingTextBoxFlag xmlns:ma14="http://schemas.microsoft.com/office/mac/drawingml/2011/main" val="0"/>
+            </a:ext>
+          </a:extLst>
+        </p:spPr>
+        <p:txBody>
+          <a:bodyPr/>
+          <a:lstStyle>
+            <a:lvl1pPr>
+              <a:defRPr sz="1000">
+                <a:solidFill>
+                  <a:srgbClr val="8A9A9B"/>
+                </a:solidFill>
+              </a:defRPr>
+            </a:lvl1pPr>
+          </a:lstStyle>
+          <a:p>
+            <a:pPr algn="r"/>
+            <a:fld id="{F7021451-1387-4CA6-816F-3879F97B5CBC}" type="slidenum">
+              <a:rPr b="0" lang="en-US"/>
+              <a:t>2</a:t>
+            </a:fld>
+            <a:endParaRPr lang="en-US"/>
+          </a:p>
+        </p:txBody>
+      </p:sp>
+      <p:sp>
+        <p:nvSpPr>
+          <p:cNvPr id="26" name="badge 1"/>
           <p:cNvSpPr/>
           <p:nvPr/>
         </p:nvSpPr>
         <p:spPr>
           <a:xfrm>
-            <a:off x="548640" y="3840479"/>
+            <a:off x="548640" y="1463040"/>
             <a:ext cx="685800" cy="685800"/>
           </a:xfrm>
           <a:prstGeom prst="ellipse">
@@ -4337,20 +4662,20 @@
                   <a:srgbClr val="FFFFFF"/>
                 </a:solidFill>
               </a:rPr>
-              <a:t>3</a:t>
-            </a:r>
-          </a:p>
-        </p:txBody>
-      </p:sp>
-      <p:sp>
-        <p:nvSpPr>
-          <p:cNvPr id="33" name="TextBox 32"/>
+              <a:t>1</a:t>
+            </a:r>
+          </a:p>
+        </p:txBody>
+      </p:sp>
+      <p:sp>
+        <p:nvSpPr>
+          <p:cNvPr id="27" name="TextBox 26"/>
           <p:cNvSpPr txBox="1"/>
           <p:nvPr/>
         </p:nvSpPr>
         <p:spPr>
           <a:xfrm>
-            <a:off x="1463040" y="3749039"/>
+            <a:off x="1463040" y="1371600"/>
             <a:ext cx="5577840" cy="411480"/>
           </a:xfrm>
           <a:prstGeom prst="rect">
@@ -4375,20 +4700,20 @@
                   <a:srgbClr val="12262B"/>
                 </a:solidFill>
               </a:rPr>
-              <a:t>Operating envelope</a:t>
-            </a:r>
-          </a:p>
-        </p:txBody>
-      </p:sp>
-      <p:sp>
-        <p:nvSpPr>
-          <p:cNvPr id="34" name="TextBox 33"/>
+              <a:t>Cost model</a:t>
+            </a:r>
+          </a:p>
+        </p:txBody>
+      </p:sp>
+      <p:sp>
+        <p:nvSpPr>
+          <p:cNvPr id="28" name="TextBox 27"/>
           <p:cNvSpPr txBox="1"/>
           <p:nvPr/>
         </p:nvSpPr>
         <p:spPr>
           <a:xfrm>
-            <a:off x="1463040" y="4187952"/>
+            <a:off x="1463040" y="1810512"/>
             <a:ext cx="5577840" cy="640080"/>
           </a:xfrm>
           <a:prstGeom prst="rect">
@@ -4413,20 +4738,20 @@
                   <a:srgbClr val="5E6E70"/>
                 </a:solidFill>
               </a:rPr>
-              <a:t>Pays above 2× breakdown cost, needs replacement within ~2 days</a:t>
-            </a:r>
-          </a:p>
-        </p:txBody>
-      </p:sp>
-      <p:sp>
-        <p:nvSpPr>
-          <p:cNvPr id="35" name="badge 4"/>
+              <a:t>Reactive, preventive and condition-based replayed on real run-to-failure data</a:t>
+            </a:r>
+          </a:p>
+        </p:txBody>
+      </p:sp>
+      <p:sp>
+        <p:nvSpPr>
+          <p:cNvPr id="29" name="badge 2"/>
           <p:cNvSpPr/>
           <p:nvPr/>
         </p:nvSpPr>
         <p:spPr>
           <a:xfrm>
-            <a:off x="548640" y="5029200"/>
+            <a:off x="548640" y="2651760"/>
             <a:ext cx="685800" cy="685800"/>
           </a:xfrm>
           <a:prstGeom prst="ellipse">
@@ -4465,20 +4790,20 @@
                   <a:srgbClr val="FFFFFF"/>
                 </a:solidFill>
               </a:rPr>
-              <a:t>4</a:t>
-            </a:r>
-          </a:p>
-        </p:txBody>
-      </p:sp>
-      <p:sp>
-        <p:nvSpPr>
-          <p:cNvPr id="36" name="TextBox 35"/>
+              <a:t>2</a:t>
+            </a:r>
+          </a:p>
+        </p:txBody>
+      </p:sp>
+      <p:sp>
+        <p:nvSpPr>
+          <p:cNvPr id="30" name="TextBox 29"/>
           <p:cNvSpPr txBox="1"/>
           <p:nvPr/>
         </p:nvSpPr>
         <p:spPr>
           <a:xfrm>
-            <a:off x="1463040" y="4937760"/>
+            <a:off x="1463040" y="2560320"/>
             <a:ext cx="5577840" cy="411480"/>
           </a:xfrm>
           <a:prstGeom prst="rect">
@@ -4503,20 +4828,20 @@
                   <a:srgbClr val="12262B"/>
                 </a:solidFill>
               </a:rPr>
-              <a:t>Two negative results</a:t>
-            </a:r>
-          </a:p>
-        </p:txBody>
-      </p:sp>
-      <p:sp>
-        <p:nvSpPr>
-          <p:cNvPr id="37" name="TextBox 36"/>
+              <a:t>Complementary alarms</a:t>
+            </a:r>
+          </a:p>
+        </p:txBody>
+      </p:sp>
+      <p:sp>
+        <p:nvSpPr>
+          <p:cNvPr id="31" name="TextBox 30"/>
           <p:cNvSpPr txBox="1"/>
           <p:nvPr/>
         </p:nvSpPr>
         <p:spPr>
           <a:xfrm>
-            <a:off x="1463040" y="5376672"/>
+            <a:off x="1463040" y="2999232"/>
             <a:ext cx="5577840" cy="640080"/>
           </a:xfrm>
           <a:prstGeom prst="rect">
@@ -4541,29 +4866,27 @@
                   <a:srgbClr val="5E6E70"/>
                 </a:solidFill>
               </a:rPr>
-              <a:t>RUL prediction and a foundation model don’t help with 4 failures</a:t>
-            </a:r>
-          </a:p>
-        </p:txBody>
-      </p:sp>
-      <p:sp>
-        <p:nvSpPr>
-          <p:cNvPr id="38" name="limits"/>
+              <a:t>Either alarm catches all 4 in 27/27 threshold settings: AI is insurance</a:t>
+            </a:r>
+          </a:p>
+        </p:txBody>
+      </p:sp>
+      <p:sp>
+        <p:nvSpPr>
+          <p:cNvPr id="32" name="badge 3"/>
           <p:cNvSpPr/>
           <p:nvPr/>
         </p:nvSpPr>
         <p:spPr>
           <a:xfrm>
-            <a:off x="7498079" y="1371600"/>
-            <a:ext cx="4114800" cy="4023360"/>
-          </a:xfrm>
-          <a:prstGeom prst="roundRect">
-            <a:avLst>
-              <a:gd name="adj" fmla="val 8000"/>
-            </a:avLst>
+            <a:off x="548640" y="3840479"/>
+            <a:ext cx="685800" cy="685800"/>
+          </a:xfrm>
+          <a:prstGeom prst="ellipse">
+            <a:avLst/>
           </a:prstGeom>
           <a:solidFill>
-            <a:schemeClr val="bg2"/>
+            <a:srgbClr val="F26B4F"/>
           </a:solidFill>
           <a:ln>
             <a:noFill/>
@@ -4585,23 +4908,31 @@
           </a:fontRef>
         </p:style>
         <p:txBody>
-          <a:bodyPr rtlCol="0" anchor="ctr"/>
+          <a:bodyPr rtlCol="0" anchor="ctr" lIns="0" rIns="0" tIns="0" bIns="0"/>
           <a:lstStyle/>
           <a:p>
             <a:pPr algn="ctr"/>
-          </a:p>
-        </p:txBody>
-      </p:sp>
-      <p:sp>
-        <p:nvSpPr>
-          <p:cNvPr id="39" name="TextBox 38"/>
+            <a:r>
+              <a:rPr sz="2000" b="1">
+                <a:solidFill>
+                  <a:srgbClr val="FFFFFF"/>
+                </a:solidFill>
+              </a:rPr>
+              <a:t>3</a:t>
+            </a:r>
+          </a:p>
+        </p:txBody>
+      </p:sp>
+      <p:sp>
+        <p:nvSpPr>
+          <p:cNvPr id="33" name="TextBox 32"/>
           <p:cNvSpPr txBox="1"/>
           <p:nvPr/>
         </p:nvSpPr>
         <p:spPr>
           <a:xfrm>
-            <a:off x="7772400" y="1554480"/>
-            <a:ext cx="3566160" cy="3749039"/>
+            <a:off x="1463040" y="3749039"/>
+            <a:ext cx="5577840" cy="411480"/>
           </a:xfrm>
           <a:prstGeom prst="rect">
             <a:avLst/>
@@ -4616,7 +4947,7 @@
           <a:p>
             <a:pPr algn="l">
               <a:spcAft>
-                <a:spcPts val="1200"/>
+                <a:spcPts val="600"/>
               </a:spcAft>
             </a:pPr>
             <a:r>
@@ -4625,17 +4956,267 @@
                   <a:srgbClr val="12262B"/>
                 </a:solidFill>
               </a:rPr>
-              <a:t>Limits</a:t>
-            </a:r>
-          </a:p>
+              <a:t>Operating envelope</a:t>
+            </a:r>
+          </a:p>
+        </p:txBody>
+      </p:sp>
+      <p:sp>
+        <p:nvSpPr>
+          <p:cNvPr id="34" name="TextBox 33"/>
+          <p:cNvSpPr txBox="1"/>
+          <p:nvPr/>
+        </p:nvSpPr>
+        <p:spPr>
+          <a:xfrm>
+            <a:off x="1463040" y="4187952"/>
+            <a:ext cx="5577840" cy="640080"/>
+          </a:xfrm>
+          <a:prstGeom prst="rect">
+            <a:avLst/>
+          </a:prstGeom>
+          <a:noFill/>
+        </p:spPr>
+        <p:txBody>
+          <a:bodyPr wrap="square" anchor="t" lIns="0" rIns="0" tIns="0" bIns="0">
+            <a:spAutoFit/>
+          </a:bodyPr>
+          <a:lstStyle/>
           <a:p>
             <a:pPr algn="l">
               <a:spcAft>
-                <a:spcPts val="1200"/>
+                <a:spcPts val="600"/>
               </a:spcAft>
             </a:pPr>
             <a:r>
-              <a:rPr sz="1600" b="0">
+              <a:rPr sz="1500" b="0">
+                <a:solidFill>
+                  <a:srgbClr val="5E6E70"/>
+                </a:solidFill>
+              </a:rPr>
+              <a:t>Pays above 2× breakdown cost, needs replacement within ~2 days</a:t>
+            </a:r>
+          </a:p>
+        </p:txBody>
+      </p:sp>
+      <p:sp>
+        <p:nvSpPr>
+          <p:cNvPr id="35" name="badge 4"/>
+          <p:cNvSpPr/>
+          <p:nvPr/>
+        </p:nvSpPr>
+        <p:spPr>
+          <a:xfrm>
+            <a:off x="548640" y="5029200"/>
+            <a:ext cx="685800" cy="685800"/>
+          </a:xfrm>
+          <a:prstGeom prst="ellipse">
+            <a:avLst/>
+          </a:prstGeom>
+          <a:solidFill>
+            <a:srgbClr val="F26B4F"/>
+          </a:solidFill>
+          <a:ln>
+            <a:noFill/>
+          </a:ln>
+          <a:effectLst/>
+        </p:spPr>
+        <p:style>
+          <a:lnRef idx="1">
+            <a:schemeClr val="accent1"/>
+          </a:lnRef>
+          <a:fillRef idx="3">
+            <a:schemeClr val="accent1"/>
+          </a:fillRef>
+          <a:effectRef idx="2">
+            <a:schemeClr val="accent1"/>
+          </a:effectRef>
+          <a:fontRef idx="minor">
+            <a:schemeClr val="lt1"/>
+          </a:fontRef>
+        </p:style>
+        <p:txBody>
+          <a:bodyPr rtlCol="0" anchor="ctr" lIns="0" rIns="0" tIns="0" bIns="0"/>
+          <a:lstStyle/>
+          <a:p>
+            <a:pPr algn="ctr"/>
+            <a:r>
+              <a:rPr sz="2000" b="1">
+                <a:solidFill>
+                  <a:srgbClr val="FFFFFF"/>
+                </a:solidFill>
+              </a:rPr>
+              <a:t>4</a:t>
+            </a:r>
+          </a:p>
+        </p:txBody>
+      </p:sp>
+      <p:sp>
+        <p:nvSpPr>
+          <p:cNvPr id="36" name="TextBox 35"/>
+          <p:cNvSpPr txBox="1"/>
+          <p:nvPr/>
+        </p:nvSpPr>
+        <p:spPr>
+          <a:xfrm>
+            <a:off x="1463040" y="4937760"/>
+            <a:ext cx="5577840" cy="411480"/>
+          </a:xfrm>
+          <a:prstGeom prst="rect">
+            <a:avLst/>
+          </a:prstGeom>
+          <a:noFill/>
+        </p:spPr>
+        <p:txBody>
+          <a:bodyPr wrap="square" anchor="t" lIns="0" rIns="0" tIns="0" bIns="0">
+            <a:spAutoFit/>
+          </a:bodyPr>
+          <a:lstStyle/>
+          <a:p>
+            <a:pPr algn="l">
+              <a:spcAft>
+                <a:spcPts val="600"/>
+              </a:spcAft>
+            </a:pPr>
+            <a:r>
+              <a:rPr sz="2000" b="1">
+                <a:solidFill>
+                  <a:srgbClr val="12262B"/>
+                </a:solidFill>
+              </a:rPr>
+              <a:t>Two negative results</a:t>
+            </a:r>
+          </a:p>
+        </p:txBody>
+      </p:sp>
+      <p:sp>
+        <p:nvSpPr>
+          <p:cNvPr id="37" name="TextBox 36"/>
+          <p:cNvSpPr txBox="1"/>
+          <p:nvPr/>
+        </p:nvSpPr>
+        <p:spPr>
+          <a:xfrm>
+            <a:off x="1463040" y="5376672"/>
+            <a:ext cx="5577840" cy="640080"/>
+          </a:xfrm>
+          <a:prstGeom prst="rect">
+            <a:avLst/>
+          </a:prstGeom>
+          <a:noFill/>
+        </p:spPr>
+        <p:txBody>
+          <a:bodyPr wrap="square" anchor="t" lIns="0" rIns="0" tIns="0" bIns="0">
+            <a:spAutoFit/>
+          </a:bodyPr>
+          <a:lstStyle/>
+          <a:p>
+            <a:pPr algn="l">
+              <a:spcAft>
+                <a:spcPts val="600"/>
+              </a:spcAft>
+            </a:pPr>
+            <a:r>
+              <a:rPr sz="1500" b="0">
+                <a:solidFill>
+                  <a:srgbClr val="5E6E70"/>
+                </a:solidFill>
+              </a:rPr>
+              <a:t>RUL prediction and a foundation model don’t help with 4 failures</a:t>
+            </a:r>
+          </a:p>
+        </p:txBody>
+      </p:sp>
+      <p:sp>
+        <p:nvSpPr>
+          <p:cNvPr id="38" name="limits"/>
+          <p:cNvSpPr/>
+          <p:nvPr/>
+        </p:nvSpPr>
+        <p:spPr>
+          <a:xfrm>
+            <a:off x="7498079" y="1371600"/>
+            <a:ext cx="4114800" cy="4023360"/>
+          </a:xfrm>
+          <a:prstGeom prst="roundRect">
+            <a:avLst>
+              <a:gd name="adj" fmla="val 8000"/>
+            </a:avLst>
+          </a:prstGeom>
+          <a:solidFill>
+            <a:schemeClr val="bg2"/>
+          </a:solidFill>
+          <a:ln>
+            <a:noFill/>
+          </a:ln>
+          <a:effectLst/>
+        </p:spPr>
+        <p:style>
+          <a:lnRef idx="1">
+            <a:schemeClr val="accent1"/>
+          </a:lnRef>
+          <a:fillRef idx="3">
+            <a:schemeClr val="accent1"/>
+          </a:fillRef>
+          <a:effectRef idx="2">
+            <a:schemeClr val="accent1"/>
+          </a:effectRef>
+          <a:fontRef idx="minor">
+            <a:schemeClr val="lt1"/>
+          </a:fontRef>
+        </p:style>
+        <p:txBody>
+          <a:bodyPr rtlCol="0" anchor="ctr"/>
+          <a:lstStyle/>
+          <a:p>
+            <a:pPr algn="ctr"/>
+          </a:p>
+        </p:txBody>
+      </p:sp>
+      <p:sp>
+        <p:nvSpPr>
+          <p:cNvPr id="39" name="TextBox 38"/>
+          <p:cNvSpPr txBox="1"/>
+          <p:nvPr/>
+        </p:nvSpPr>
+        <p:spPr>
+          <a:xfrm>
+            <a:off x="7772400" y="1554480"/>
+            <a:ext cx="3566160" cy="3749039"/>
+          </a:xfrm>
+          <a:prstGeom prst="rect">
+            <a:avLst/>
+          </a:prstGeom>
+          <a:noFill/>
+        </p:spPr>
+        <p:txBody>
+          <a:bodyPr wrap="square" anchor="t" lIns="0" rIns="0" tIns="0" bIns="0">
+            <a:spAutoFit/>
+          </a:bodyPr>
+          <a:lstStyle/>
+          <a:p>
+            <a:pPr algn="l">
+              <a:spcAft>
+                <a:spcPts val="800"/>
+              </a:spcAft>
+            </a:pPr>
+            <a:r>
+              <a:rPr sz="2000" b="1">
+                <a:solidFill>
+                  <a:srgbClr val="12262B"/>
+                </a:solidFill>
+              </a:rPr>
+              <a:t>Limits</a:t>
+            </a:r>
+          </a:p>
+          <a:p>
+            <a:pPr algn="l">
+              <a:spcAft>
+                <a:spcPts val="800"/>
+              </a:spcAft>
+            </a:pPr>
+            <a:r>
+              <a:rPr sz="1500" b="0">
                 <a:solidFill>
                   <a:srgbClr val="12262B"/>
                 </a:solidFill>
@@ -4646,26 +5227,41 @@
           <a:p>
             <a:pPr algn="l">
               <a:spcAft>
-                <a:spcPts val="1200"/>
+                <a:spcPts val="800"/>
               </a:spcAft>
             </a:pPr>
             <a:r>
-              <a:rPr sz="1600" b="0">
+              <a:rPr sz="1500" b="0">
                 <a:solidFill>
                   <a:srgbClr val="12262B"/>
                 </a:solidFill>
               </a:rPr>
-              <a:t>Both alarm thresholds were set on these same 12 bearings</a:t>
+              <a:t>Thresholds set on these 12 bearings (4/4 still holds in 27/27 settings)</a:t>
             </a:r>
           </a:p>
           <a:p>
             <a:pPr algn="l">
               <a:spcAft>
-                <a:spcPts val="1200"/>
+                <a:spcPts val="800"/>
               </a:spcAft>
             </a:pPr>
             <a:r>
-              <a:rPr sz="1600" b="0">
+              <a:rPr sz="1500" b="0">
+                <a:solidFill>
+                  <a:srgbClr val="12262B"/>
+                </a:solidFill>
+              </a:rPr>
+              <a:t>Cheapest single alarm rule varies by test and false-alarm cost</a:t>
+            </a:r>
+          </a:p>
+          <a:p>
+            <a:pPr algn="l">
+              <a:spcAft>
+                <a:spcPts val="800"/>
+              </a:spcAft>
+            </a:pPr>
+            <a:r>
+              <a:rPr sz="1500" b="0">
                 <a:solidFill>
                   <a:srgbClr val="12262B"/>
                 </a:solidFill>
@@ -4676,11 +5272,11 @@
           <a:p>
             <a:pPr algn="l">
               <a:spcAft>
-                <a:spcPts val="1200"/>
+                <a:spcPts val="800"/>
               </a:spcAft>
             </a:pPr>
             <a:r>
-              <a:rPr sz="1600" b="0">
+              <a:rPr sz="1500" b="0">
                 <a:solidFill>
                   <a:srgbClr val="12262B"/>
                 </a:solidFill>
@@ -4843,7 +5439,7 @@
                   <a:schemeClr val="accent6"/>
                 </a:solidFill>
               </a:rPr>
-              <a:t>Limit: 4 failures; thresholds set on the same data</a:t>
+              <a:t>Holds over 27 threshold settings; limit: only 4 failures</a:t>
             </a:r>
             <a:endParaRPr lang="en-US" sz="2000" dirty="0"/>
           </a:p>
@@ -9480,7 +10076,7 @@
                   <a:srgbClr val="12262B"/>
                 </a:solidFill>
               </a:rPr>
-              <a:t>Where AI helps</a:t>
+              <a:t>At default thresholds</a:t>
             </a:r>
           </a:p>
           <a:p>
@@ -9564,7 +10160,7 @@
           <a:lstStyle/>
           <a:p>
             <a:r>
-              <a:t>What didn’t work: predicting the hours left</a:t>
+              <a:t>Robustness: either alarm catches all 4 at every threshold</a:t>
             </a:r>
           </a:p>
         </p:txBody>
@@ -9614,16 +10210,548 @@
           </a:p>
         </p:txBody>
       </p:sp>
-      <p:sp>
-        <p:nvSpPr>
-          <p:cNvPr id="26" name="negative Calibrated RUL bound"/>
+      <p:graphicFrame>
+        <p:nvGraphicFramePr>
+          <p:cNvPr id="26" name="Table 25"/>
+          <p:cNvGraphicFramePr>
+            <a:graphicFrameLocks noGrp="1"/>
+          </p:cNvGraphicFramePr>
+          <p:nvPr/>
+        </p:nvGraphicFramePr>
+        <p:xfrm>
+          <a:off x="548640" y="1371600"/>
+          <a:ext cx="8138160" cy="3886200"/>
+        </p:xfrm>
+        <a:graphic>
+          <a:graphicData uri="http://schemas.openxmlformats.org/drawingml/2006/table">
+            <a:tbl>
+              <a:tblPr firstRow="1">
+                <a:tableStyleId>{5C22544A-7EE6-4342-B048-85BDC9FD1C3A}</a:tableStyleId>
+              </a:tblPr>
+              <a:tblGrid>
+                <a:gridCol w="2651760"/>
+                <a:gridCol w="5486400"/>
+              </a:tblGrid>
+              <a:tr h="777240">
+                <a:tc>
+                  <a:txBody>
+                    <a:bodyPr wrap="square"/>
+                    <a:lstStyle/>
+                    <a:p>
+                      <a:pPr algn="l"/>
+                      <a:r>
+                        <a:rPr sz="1400" b="1">
+                          <a:solidFill>
+                            <a:srgbClr val="FFFFFF"/>
+                          </a:solidFill>
+                        </a:rPr>
+                        <a:t>Check</a:t>
+                      </a:r>
+                    </a:p>
+                  </a:txBody>
+                  <a:tcPr anchor="ctr" marL="73152" marR="73152">
+                    <a:lnL w="9525">
+                      <a:solidFill>
+                        <a:srgbClr val="D3E2E0"/>
+                      </a:solidFill>
+                    </a:lnL>
+                    <a:lnR w="9525">
+                      <a:solidFill>
+                        <a:srgbClr val="D3E2E0"/>
+                      </a:solidFill>
+                    </a:lnR>
+                    <a:lnT w="9525">
+                      <a:solidFill>
+                        <a:srgbClr val="D3E2E0"/>
+                      </a:solidFill>
+                    </a:lnT>
+                    <a:lnB w="9525">
+                      <a:solidFill>
+                        <a:srgbClr val="D3E2E0"/>
+                      </a:solidFill>
+                    </a:lnB>
+                    <a:solidFill>
+                      <a:srgbClr val="0F4C5C"/>
+                    </a:solidFill>
+                  </a:tcPr>
+                </a:tc>
+                <a:tc>
+                  <a:txBody>
+                    <a:bodyPr wrap="square"/>
+                    <a:lstStyle/>
+                    <a:p>
+                      <a:pPr algn="l"/>
+                      <a:r>
+                        <a:rPr sz="1400" b="1">
+                          <a:solidFill>
+                            <a:srgbClr val="FFFFFF"/>
+                          </a:solidFill>
+                        </a:rPr>
+                        <a:t>Result</a:t>
+                      </a:r>
+                    </a:p>
+                  </a:txBody>
+                  <a:tcPr anchor="ctr" marL="73152" marR="73152">
+                    <a:lnL w="9525">
+                      <a:solidFill>
+                        <a:srgbClr val="D3E2E0"/>
+                      </a:solidFill>
+                    </a:lnL>
+                    <a:lnR w="9525">
+                      <a:solidFill>
+                        <a:srgbClr val="D3E2E0"/>
+                      </a:solidFill>
+                    </a:lnR>
+                    <a:lnT w="9525">
+                      <a:solidFill>
+                        <a:srgbClr val="D3E2E0"/>
+                      </a:solidFill>
+                    </a:lnT>
+                    <a:lnB w="9525">
+                      <a:solidFill>
+                        <a:srgbClr val="D3E2E0"/>
+                      </a:solidFill>
+                    </a:lnB>
+                    <a:solidFill>
+                      <a:srgbClr val="0F4C5C"/>
+                    </a:solidFill>
+                  </a:tcPr>
+                </a:tc>
+              </a:tr>
+              <a:tr h="777240">
+                <a:tc>
+                  <a:txBody>
+                    <a:bodyPr wrap="square"/>
+                    <a:lstStyle/>
+                    <a:p>
+                      <a:pPr algn="l"/>
+                      <a:r>
+                        <a:rPr sz="1500" b="0">
+                          <a:solidFill>
+                            <a:srgbClr val="12262B"/>
+                          </a:solidFill>
+                        </a:rPr>
+                        <a:t>27 threshold settings</a:t>
+                      </a:r>
+                    </a:p>
+                  </a:txBody>
+                  <a:tcPr anchor="ctr" marL="73152" marR="73152">
+                    <a:lnL w="9525">
+                      <a:solidFill>
+                        <a:srgbClr val="D3E2E0"/>
+                      </a:solidFill>
+                    </a:lnL>
+                    <a:lnR w="9525">
+                      <a:solidFill>
+                        <a:srgbClr val="D3E2E0"/>
+                      </a:solidFill>
+                    </a:lnR>
+                    <a:lnT w="9525">
+                      <a:solidFill>
+                        <a:srgbClr val="D3E2E0"/>
+                      </a:solidFill>
+                    </a:lnT>
+                    <a:lnB w="9525">
+                      <a:solidFill>
+                        <a:srgbClr val="D3E2E0"/>
+                      </a:solidFill>
+                    </a:lnB>
+                    <a:solidFill>
+                      <a:srgbClr val="FFFFFF"/>
+                    </a:solidFill>
+                  </a:tcPr>
+                </a:tc>
+                <a:tc>
+                  <a:txBody>
+                    <a:bodyPr wrap="square"/>
+                    <a:lstStyle/>
+                    <a:p>
+                      <a:pPr algn="l"/>
+                      <a:r>
+                        <a:rPr sz="1500" b="0">
+                          <a:solidFill>
+                            <a:srgbClr val="12262B"/>
+                          </a:solidFill>
+                        </a:rPr>
+                        <a:t>Physics OR AI: 4/4 in 27/27, cost 0.81-1.08. Physics alone: 4/4 in 9/27</a:t>
+                      </a:r>
+                    </a:p>
+                  </a:txBody>
+                  <a:tcPr anchor="ctr" marL="73152" marR="73152">
+                    <a:lnL w="9525">
+                      <a:solidFill>
+                        <a:srgbClr val="D3E2E0"/>
+                      </a:solidFill>
+                    </a:lnL>
+                    <a:lnR w="9525">
+                      <a:solidFill>
+                        <a:srgbClr val="D3E2E0"/>
+                      </a:solidFill>
+                    </a:lnR>
+                    <a:lnT w="9525">
+                      <a:solidFill>
+                        <a:srgbClr val="D3E2E0"/>
+                      </a:solidFill>
+                    </a:lnT>
+                    <a:lnB w="9525">
+                      <a:solidFill>
+                        <a:srgbClr val="D3E2E0"/>
+                      </a:solidFill>
+                    </a:lnB>
+                    <a:solidFill>
+                      <a:srgbClr val="FFFFFF"/>
+                    </a:solidFill>
+                  </a:tcPr>
+                </a:tc>
+              </a:tr>
+              <a:tr h="777240">
+                <a:tc>
+                  <a:txBody>
+                    <a:bodyPr wrap="square"/>
+                    <a:lstStyle/>
+                    <a:p>
+                      <a:pPr algn="l"/>
+                      <a:r>
+                        <a:rPr sz="1500" b="0">
+                          <a:solidFill>
+                            <a:srgbClr val="12262B"/>
+                          </a:solidFill>
+                        </a:rPr>
+                        <a:t>Leave one test out</a:t>
+                      </a:r>
+                    </a:p>
+                  </a:txBody>
+                  <a:tcPr anchor="ctr" marL="73152" marR="73152">
+                    <a:lnL w="9525">
+                      <a:solidFill>
+                        <a:srgbClr val="D3E2E0"/>
+                      </a:solidFill>
+                    </a:lnL>
+                    <a:lnR w="9525">
+                      <a:solidFill>
+                        <a:srgbClr val="D3E2E0"/>
+                      </a:solidFill>
+                    </a:lnR>
+                    <a:lnT w="9525">
+                      <a:solidFill>
+                        <a:srgbClr val="D3E2E0"/>
+                      </a:solidFill>
+                    </a:lnT>
+                    <a:lnB w="9525">
+                      <a:solidFill>
+                        <a:srgbClr val="D3E2E0"/>
+                      </a:solidFill>
+                    </a:lnB>
+                    <a:solidFill>
+                      <a:srgbClr val="FFFFFF"/>
+                    </a:solidFill>
+                  </a:tcPr>
+                </a:tc>
+                <a:tc>
+                  <a:txBody>
+                    <a:bodyPr wrap="square"/>
+                    <a:lstStyle/>
+                    <a:p>
+                      <a:pPr algn="l"/>
+                      <a:r>
+                        <a:rPr sz="1500" b="0">
+                          <a:solidFill>
+                            <a:srgbClr val="12262B"/>
+                          </a:solidFill>
+                        </a:rPr>
+                        <a:t>Condition-based beats reactive (3.9-7.6) and preventive (1.2-3.5) every time; cheapest alarm rule varies</a:t>
+                      </a:r>
+                    </a:p>
+                  </a:txBody>
+                  <a:tcPr anchor="ctr" marL="73152" marR="73152">
+                    <a:lnL w="9525">
+                      <a:solidFill>
+                        <a:srgbClr val="D3E2E0"/>
+                      </a:solidFill>
+                    </a:lnL>
+                    <a:lnR w="9525">
+                      <a:solidFill>
+                        <a:srgbClr val="D3E2E0"/>
+                      </a:solidFill>
+                    </a:lnR>
+                    <a:lnT w="9525">
+                      <a:solidFill>
+                        <a:srgbClr val="D3E2E0"/>
+                      </a:solidFill>
+                    </a:lnT>
+                    <a:lnB w="9525">
+                      <a:solidFill>
+                        <a:srgbClr val="D3E2E0"/>
+                      </a:solidFill>
+                    </a:lnB>
+                    <a:solidFill>
+                      <a:srgbClr val="FFFFFF"/>
+                    </a:solidFill>
+                  </a:tcPr>
+                </a:tc>
+              </a:tr>
+              <a:tr h="777240">
+                <a:tc>
+                  <a:txBody>
+                    <a:bodyPr wrap="square"/>
+                    <a:lstStyle/>
+                    <a:p>
+                      <a:pPr algn="l"/>
+                      <a:r>
+                        <a:rPr sz="1500" b="0">
+                          <a:solidFill>
+                            <a:srgbClr val="12262B"/>
+                          </a:solidFill>
+                        </a:rPr>
+                        <a:t>False alarm 5× a planned job</a:t>
+                      </a:r>
+                    </a:p>
+                  </a:txBody>
+                  <a:tcPr anchor="ctr" marL="73152" marR="73152">
+                    <a:lnL w="9525">
+                      <a:solidFill>
+                        <a:srgbClr val="D3E2E0"/>
+                      </a:solidFill>
+                    </a:lnL>
+                    <a:lnR w="9525">
+                      <a:solidFill>
+                        <a:srgbClr val="D3E2E0"/>
+                      </a:solidFill>
+                    </a:lnR>
+                    <a:lnT w="9525">
+                      <a:solidFill>
+                        <a:srgbClr val="D3E2E0"/>
+                      </a:solidFill>
+                    </a:lnT>
+                    <a:lnB w="9525">
+                      <a:solidFill>
+                        <a:srgbClr val="D3E2E0"/>
+                      </a:solidFill>
+                    </a:lnB>
+                    <a:solidFill>
+                      <a:srgbClr val="FFFFFF"/>
+                    </a:solidFill>
+                  </a:tcPr>
+                </a:tc>
+                <a:tc>
+                  <a:txBody>
+                    <a:bodyPr wrap="square"/>
+                    <a:lstStyle/>
+                    <a:p>
+                      <a:pPr algn="l"/>
+                      <a:r>
+                        <a:rPr sz="1500" b="0">
+                          <a:solidFill>
+                            <a:srgbClr val="12262B"/>
+                          </a:solidFill>
+                        </a:rPr>
+                        <a:t>AI alone cheapest (1.61 vs 1.91 for either alarm)</a:t>
+                      </a:r>
+                    </a:p>
+                  </a:txBody>
+                  <a:tcPr anchor="ctr" marL="73152" marR="73152">
+                    <a:lnL w="9525">
+                      <a:solidFill>
+                        <a:srgbClr val="D3E2E0"/>
+                      </a:solidFill>
+                    </a:lnL>
+                    <a:lnR w="9525">
+                      <a:solidFill>
+                        <a:srgbClr val="D3E2E0"/>
+                      </a:solidFill>
+                    </a:lnR>
+                    <a:lnT w="9525">
+                      <a:solidFill>
+                        <a:srgbClr val="D3E2E0"/>
+                      </a:solidFill>
+                    </a:lnT>
+                    <a:lnB w="9525">
+                      <a:solidFill>
+                        <a:srgbClr val="D3E2E0"/>
+                      </a:solidFill>
+                    </a:lnB>
+                    <a:solidFill>
+                      <a:srgbClr val="FFFFFF"/>
+                    </a:solidFill>
+                  </a:tcPr>
+                </a:tc>
+              </a:tr>
+              <a:tr h="777240">
+                <a:tc>
+                  <a:txBody>
+                    <a:bodyPr wrap="square"/>
+                    <a:lstStyle/>
+                    <a:p>
+                      <a:pPr algn="l"/>
+                      <a:r>
+                        <a:rPr sz="1500" b="0">
+                          <a:solidFill>
+                            <a:srgbClr val="12262B"/>
+                          </a:solidFill>
+                        </a:rPr>
+                        <a:t>Set 1 B3 cross-talk from B4?</a:t>
+                      </a:r>
+                    </a:p>
+                  </a:txBody>
+                  <a:tcPr anchor="ctr" marL="73152" marR="73152">
+                    <a:lnL w="9525">
+                      <a:solidFill>
+                        <a:srgbClr val="D3E2E0"/>
+                      </a:solidFill>
+                    </a:lnL>
+                    <a:lnR w="9525">
+                      <a:solidFill>
+                        <a:srgbClr val="D3E2E0"/>
+                      </a:solidFill>
+                    </a:lnR>
+                    <a:lnT w="9525">
+                      <a:solidFill>
+                        <a:srgbClr val="D3E2E0"/>
+                      </a:solidFill>
+                    </a:lnT>
+                    <a:lnB w="9525">
+                      <a:solidFill>
+                        <a:srgbClr val="D3E2E0"/>
+                      </a:solidFill>
+                    </a:lnB>
+                    <a:solidFill>
+                      <a:srgbClr val="FFFFFF"/>
+                    </a:solidFill>
+                  </a:tcPr>
+                </a:tc>
+                <a:tc>
+                  <a:txBody>
+                    <a:bodyPr wrap="square"/>
+                    <a:lstStyle/>
+                    <a:p>
+                      <a:pPr algn="l"/>
+                      <a:r>
+                        <a:rPr sz="1500" b="0">
+                          <a:solidFill>
+                            <a:srgbClr val="12262B"/>
+                          </a:solidFill>
+                        </a:rPr>
+                        <a:t>No: B3's AI alarm is its own impacts (kurtosis, peak), not B4's roller rhythm</a:t>
+                      </a:r>
+                    </a:p>
+                  </a:txBody>
+                  <a:tcPr anchor="ctr" marL="73152" marR="73152">
+                    <a:lnL w="9525">
+                      <a:solidFill>
+                        <a:srgbClr val="D3E2E0"/>
+                      </a:solidFill>
+                    </a:lnL>
+                    <a:lnR w="9525">
+                      <a:solidFill>
+                        <a:srgbClr val="D3E2E0"/>
+                      </a:solidFill>
+                    </a:lnR>
+                    <a:lnT w="9525">
+                      <a:solidFill>
+                        <a:srgbClr val="D3E2E0"/>
+                      </a:solidFill>
+                    </a:lnT>
+                    <a:lnB w="9525">
+                      <a:solidFill>
+                        <a:srgbClr val="D3E2E0"/>
+                      </a:solidFill>
+                    </a:lnB>
+                    <a:solidFill>
+                      <a:srgbClr val="FFFFFF"/>
+                    </a:solidFill>
+                  </a:tcPr>
+                </a:tc>
+              </a:tr>
+            </a:tbl>
+          </a:graphicData>
+        </a:graphic>
+      </p:graphicFrame>
+      <p:sp>
+        <p:nvSpPr>
+          <p:cNvPr id="27" name="stat 27 / 27"/>
+          <p:cNvSpPr txBox="1"/>
+          <p:nvPr/>
+        </p:nvSpPr>
+        <p:spPr>
+          <a:xfrm>
+            <a:off x="9052560" y="1280160"/>
+            <a:ext cx="2560320" cy="777240"/>
+          </a:xfrm>
+          <a:prstGeom prst="rect">
+            <a:avLst/>
+          </a:prstGeom>
+          <a:noFill/>
+        </p:spPr>
+        <p:txBody>
+          <a:bodyPr wrap="square" anchor="t" lIns="0" rIns="0" tIns="0" bIns="0">
+            <a:spAutoFit/>
+          </a:bodyPr>
+          <a:lstStyle/>
+          <a:p>
+            <a:pPr algn="l">
+              <a:spcAft>
+                <a:spcPts val="600"/>
+              </a:spcAft>
+            </a:pPr>
+            <a:r>
+              <a:rPr sz="4400" b="1">
+                <a:solidFill>
+                  <a:srgbClr val="3E9B5F"/>
+                </a:solidFill>
+              </a:rPr>
+              <a:t>27 / 27</a:t>
+            </a:r>
+          </a:p>
+        </p:txBody>
+      </p:sp>
+      <p:sp>
+        <p:nvSpPr>
+          <p:cNvPr id="28" name="TextBox 27"/>
+          <p:cNvSpPr txBox="1"/>
+          <p:nvPr/>
+        </p:nvSpPr>
+        <p:spPr>
+          <a:xfrm>
+            <a:off x="9052560" y="2057400"/>
+            <a:ext cx="2560320" cy="640080"/>
+          </a:xfrm>
+          <a:prstGeom prst="rect">
+            <a:avLst/>
+          </a:prstGeom>
+          <a:noFill/>
+        </p:spPr>
+        <p:txBody>
+          <a:bodyPr wrap="square" anchor="t" lIns="0" rIns="0" tIns="0" bIns="0">
+            <a:spAutoFit/>
+          </a:bodyPr>
+          <a:lstStyle/>
+          <a:p>
+            <a:pPr algn="l">
+              <a:spcAft>
+                <a:spcPts val="600"/>
+              </a:spcAft>
+            </a:pPr>
+            <a:r>
+              <a:rPr sz="1500" b="0">
+                <a:solidFill>
+                  <a:srgbClr val="5E6E70"/>
+                </a:solidFill>
+              </a:rPr>
+              <a:t>threshold settings where either alarm catches all 4</a:t>
+            </a:r>
+          </a:p>
+        </p:txBody>
+      </p:sp>
+      <p:sp>
+        <p:nvSpPr>
+          <p:cNvPr id="29" name="insurance note"/>
           <p:cNvSpPr/>
           <p:nvPr/>
         </p:nvSpPr>
         <p:spPr>
           <a:xfrm>
-            <a:off x="548640" y="1371600"/>
-            <a:ext cx="5394960" cy="4023360"/>
+            <a:off x="9052560" y="3017520"/>
+            <a:ext cx="2560320" cy="2651760"/>
           </a:xfrm>
           <a:prstGeom prst="roundRect">
             <a:avLst>
@@ -9662,14 +10790,14 @@
       </p:sp>
       <p:sp>
         <p:nvSpPr>
-          <p:cNvPr id="27" name="TextBox 26"/>
+          <p:cNvPr id="30" name="TextBox 29"/>
           <p:cNvSpPr txBox="1"/>
           <p:nvPr/>
         </p:nvSpPr>
         <p:spPr>
           <a:xfrm>
-            <a:off x="868680" y="1600200"/>
-            <a:ext cx="4754880" cy="457200"/>
+            <a:off x="9235440" y="3154680"/>
+            <a:ext cx="2194560" cy="2468880"/>
           </a:xfrm>
           <a:prstGeom prst="rect">
             <a:avLst/>
@@ -9688,37 +10816,14 @@
               </a:spcAft>
             </a:pPr>
             <a:r>
-              <a:rPr sz="2200" b="1">
+              <a:rPr sz="1800" b="1">
                 <a:solidFill>
                   <a:srgbClr val="12262B"/>
                 </a:solidFill>
               </a:rPr>
-              <a:t>Calibrated RUL bound</a:t>
-            </a:r>
-          </a:p>
-        </p:txBody>
-      </p:sp>
-      <p:sp>
-        <p:nvSpPr>
-          <p:cNvPr id="28" name="TextBox 27"/>
-          <p:cNvSpPr txBox="1"/>
-          <p:nvPr/>
-        </p:nvSpPr>
-        <p:spPr>
-          <a:xfrm>
-            <a:off x="868680" y="2194560"/>
-            <a:ext cx="4754880" cy="822960"/>
-          </a:xfrm>
-          <a:prstGeom prst="rect">
-            <a:avLst/>
-          </a:prstGeom>
-          <a:noFill/>
-        </p:spPr>
-        <p:txBody>
-          <a:bodyPr wrap="square" anchor="t" lIns="0" rIns="0" tIns="0" bIns="0">
-            <a:spAutoFit/>
-          </a:bodyPr>
-          <a:lstStyle/>
+              <a:t>AI as insurance</a:t>
+            </a:r>
+          </a:p>
           <a:p>
             <a:pPr algn="l">
               <a:spcAft>
@@ -9726,37 +10831,14 @@
               </a:spcAft>
             </a:pPr>
             <a:r>
-              <a:rPr sz="4400" b="1">
-                <a:solidFill>
-                  <a:srgbClr val="D64545"/>
+              <a:rPr sz="1500" b="0">
+                <a:solidFill>
+                  <a:srgbClr val="12262B"/>
                 </a:solidFill>
               </a:rPr>
-              <a:t>17-59 h</a:t>
-            </a:r>
-          </a:p>
-        </p:txBody>
-      </p:sp>
-      <p:sp>
-        <p:nvSpPr>
-          <p:cNvPr id="29" name="TextBox 28"/>
-          <p:cNvSpPr txBox="1"/>
-          <p:nvPr/>
-        </p:nvSpPr>
-        <p:spPr>
-          <a:xfrm>
-            <a:off x="868680" y="3017520"/>
-            <a:ext cx="4754880" cy="457200"/>
-          </a:xfrm>
-          <a:prstGeom prst="rect">
-            <a:avLst/>
-          </a:prstGeom>
-          <a:noFill/>
-        </p:spPr>
-        <p:txBody>
-          <a:bodyPr wrap="square" anchor="t" lIns="0" rIns="0" tIns="0" bIns="0">
-            <a:spAutoFit/>
-          </a:bodyPr>
-          <a:lstStyle/>
+              <a:t>Physics alone needs a lucky threshold to catch all 4</a:t>
+            </a:r>
+          </a:p>
           <a:p>
             <a:pPr algn="l">
               <a:spcAft>
@@ -9764,278 +10846,12 @@
               </a:spcAft>
             </a:pPr>
             <a:r>
-              <a:rPr sz="1500" b="0">
-                <a:solidFill>
-                  <a:srgbClr val="5E6E70"/>
+              <a:rPr sz="1500" b="1">
+                <a:solidFill>
+                  <a:srgbClr val="F26B4F"/>
                 </a:solidFill>
               </a:rPr>
-              <a:t>safety margin, as wide as the lead time</a:t>
-            </a:r>
-          </a:p>
-        </p:txBody>
-      </p:sp>
-      <p:sp>
-        <p:nvSpPr>
-          <p:cNvPr id="30" name="TextBox 29"/>
-          <p:cNvSpPr txBox="1"/>
-          <p:nvPr/>
-        </p:nvSpPr>
-        <p:spPr>
-          <a:xfrm>
-            <a:off x="868680" y="3749039"/>
-            <a:ext cx="4754880" cy="2194560"/>
-          </a:xfrm>
-          <a:prstGeom prst="rect">
-            <a:avLst/>
-          </a:prstGeom>
-          <a:noFill/>
-        </p:spPr>
-        <p:txBody>
-          <a:bodyPr wrap="square" anchor="t" lIns="0" rIns="0" tIns="0" bIns="0">
-            <a:spAutoFit/>
-          </a:bodyPr>
-          <a:lstStyle/>
-          <a:p>
-            <a:pPr algn="l">
-              <a:spcAft>
-                <a:spcPts val="1000"/>
-              </a:spcAft>
-            </a:pPr>
-            <a:r>
-              <a:rPr sz="1600" b="0">
-                <a:solidFill>
-                  <a:srgbClr val="12262B"/>
-                </a:solidFill>
-              </a:rPr>
-              <a:t>Never beats “act at the alarm” for lead times 4-48 h</a:t>
-            </a:r>
-          </a:p>
-          <a:p>
-            <a:pPr algn="l">
-              <a:spcAft>
-                <a:spcPts val="1000"/>
-              </a:spcAft>
-            </a:pPr>
-            <a:r>
-              <a:rPr sz="1600" b="0">
-                <a:solidFill>
-                  <a:srgbClr val="12262B"/>
-                </a:solidFill>
-              </a:rPr>
-              <a:t>After the alarm the bearings lasted 12, 53, 70, 97 h: too spread to learn from 3 examples</a:t>
-            </a:r>
-          </a:p>
-        </p:txBody>
-      </p:sp>
-      <p:sp>
-        <p:nvSpPr>
-          <p:cNvPr id="31" name="negative Foundation model (Chronos-2)"/>
-          <p:cNvSpPr/>
-          <p:nvPr/>
-        </p:nvSpPr>
-        <p:spPr>
-          <a:xfrm>
-            <a:off x="6217920" y="1371600"/>
-            <a:ext cx="5394960" cy="4023360"/>
-          </a:xfrm>
-          <a:prstGeom prst="roundRect">
-            <a:avLst>
-              <a:gd name="adj" fmla="val 8000"/>
-            </a:avLst>
-          </a:prstGeom>
-          <a:solidFill>
-            <a:schemeClr val="bg2"/>
-          </a:solidFill>
-          <a:ln>
-            <a:noFill/>
-          </a:ln>
-          <a:effectLst/>
-        </p:spPr>
-        <p:style>
-          <a:lnRef idx="1">
-            <a:schemeClr val="accent1"/>
-          </a:lnRef>
-          <a:fillRef idx="3">
-            <a:schemeClr val="accent1"/>
-          </a:fillRef>
-          <a:effectRef idx="2">
-            <a:schemeClr val="accent1"/>
-          </a:effectRef>
-          <a:fontRef idx="minor">
-            <a:schemeClr val="lt1"/>
-          </a:fontRef>
-        </p:style>
-        <p:txBody>
-          <a:bodyPr rtlCol="0" anchor="ctr"/>
-          <a:lstStyle/>
-          <a:p>
-            <a:pPr algn="ctr"/>
-          </a:p>
-        </p:txBody>
-      </p:sp>
-      <p:sp>
-        <p:nvSpPr>
-          <p:cNvPr id="32" name="TextBox 31"/>
-          <p:cNvSpPr txBox="1"/>
-          <p:nvPr/>
-        </p:nvSpPr>
-        <p:spPr>
-          <a:xfrm>
-            <a:off x="6537959" y="1600200"/>
-            <a:ext cx="4754880" cy="457200"/>
-          </a:xfrm>
-          <a:prstGeom prst="rect">
-            <a:avLst/>
-          </a:prstGeom>
-          <a:noFill/>
-        </p:spPr>
-        <p:txBody>
-          <a:bodyPr wrap="square" anchor="t" lIns="0" rIns="0" tIns="0" bIns="0">
-            <a:spAutoFit/>
-          </a:bodyPr>
-          <a:lstStyle/>
-          <a:p>
-            <a:pPr algn="l">
-              <a:spcAft>
-                <a:spcPts val="600"/>
-              </a:spcAft>
-            </a:pPr>
-            <a:r>
-              <a:rPr sz="2200" b="1">
-                <a:solidFill>
-                  <a:srgbClr val="12262B"/>
-                </a:solidFill>
-              </a:rPr>
-              <a:t>Foundation model (Chronos-2)</a:t>
-            </a:r>
-          </a:p>
-        </p:txBody>
-      </p:sp>
-      <p:sp>
-        <p:nvSpPr>
-          <p:cNvPr id="33" name="TextBox 32"/>
-          <p:cNvSpPr txBox="1"/>
-          <p:nvPr/>
-        </p:nvSpPr>
-        <p:spPr>
-          <a:xfrm>
-            <a:off x="6537959" y="2194560"/>
-            <a:ext cx="4754880" cy="822960"/>
-          </a:xfrm>
-          <a:prstGeom prst="rect">
-            <a:avLst/>
-          </a:prstGeom>
-          <a:noFill/>
-        </p:spPr>
-        <p:txBody>
-          <a:bodyPr wrap="square" anchor="t" lIns="0" rIns="0" tIns="0" bIns="0">
-            <a:spAutoFit/>
-          </a:bodyPr>
-          <a:lstStyle/>
-          <a:p>
-            <a:pPr algn="l">
-              <a:spcAft>
-                <a:spcPts val="600"/>
-              </a:spcAft>
-            </a:pPr>
-            <a:r>
-              <a:rPr sz="4400" b="1">
-                <a:solidFill>
-                  <a:srgbClr val="D64545"/>
-                </a:solidFill>
-              </a:rPr>
-              <a:t>56 vs 25 h</a:t>
-            </a:r>
-          </a:p>
-        </p:txBody>
-      </p:sp>
-      <p:sp>
-        <p:nvSpPr>
-          <p:cNvPr id="34" name="TextBox 33"/>
-          <p:cNvSpPr txBox="1"/>
-          <p:nvPr/>
-        </p:nvSpPr>
-        <p:spPr>
-          <a:xfrm>
-            <a:off x="6537959" y="3017520"/>
-            <a:ext cx="4754880" cy="457200"/>
-          </a:xfrm>
-          <a:prstGeom prst="rect">
-            <a:avLst/>
-          </a:prstGeom>
-          <a:noFill/>
-        </p:spPr>
-        <p:txBody>
-          <a:bodyPr wrap="square" anchor="t" lIns="0" rIns="0" tIns="0" bIns="0">
-            <a:spAutoFit/>
-          </a:bodyPr>
-          <a:lstStyle/>
-          <a:p>
-            <a:pPr algn="l">
-              <a:spcAft>
-                <a:spcPts val="600"/>
-              </a:spcAft>
-            </a:pPr>
-            <a:r>
-              <a:rPr sz="1500" b="0">
-                <a:solidFill>
-                  <a:srgbClr val="5E6E70"/>
-                </a:solidFill>
-              </a:rPr>
-              <a:t>RUL error vs gradient boosting (set 2 B1)</a:t>
-            </a:r>
-          </a:p>
-        </p:txBody>
-      </p:sp>
-      <p:sp>
-        <p:nvSpPr>
-          <p:cNvPr id="35" name="TextBox 34"/>
-          <p:cNvSpPr txBox="1"/>
-          <p:nvPr/>
-        </p:nvSpPr>
-        <p:spPr>
-          <a:xfrm>
-            <a:off x="6537959" y="3749039"/>
-            <a:ext cx="4754880" cy="2194560"/>
-          </a:xfrm>
-          <a:prstGeom prst="rect">
-            <a:avLst/>
-          </a:prstGeom>
-          <a:noFill/>
-        </p:spPr>
-        <p:txBody>
-          <a:bodyPr wrap="square" anchor="t" lIns="0" rIns="0" tIns="0" bIns="0">
-            <a:spAutoFit/>
-          </a:bodyPr>
-          <a:lstStyle/>
-          <a:p>
-            <a:pPr algn="l">
-              <a:spcAft>
-                <a:spcPts val="1000"/>
-              </a:spcAft>
-            </a:pPr>
-            <a:r>
-              <a:rPr sz="1600" b="0">
-                <a:solidFill>
-                  <a:srgbClr val="12262B"/>
-                </a:solidFill>
-              </a:rPr>
-              <a:t>Forecast the vibration levelling off; it actually accelerated</a:t>
-            </a:r>
-          </a:p>
-          <a:p>
-            <a:pPr algn="l">
-              <a:spcAft>
-                <a:spcPts val="1000"/>
-              </a:spcAft>
-            </a:pPr>
-            <a:r>
-              <a:rPr sz="1600" b="0">
-                <a:solidFill>
-                  <a:srgbClr val="12262B"/>
-                </a:solidFill>
-              </a:rPr>
-              <a:t>Pretrained forecasters continue patterns; failure breaks the pattern</a:t>
+              <a:t>Either alarm catches all 4 whatever the threshold</a:t>
             </a:r>
           </a:p>
         </p:txBody>

</xml_diff>

<commit_message>
Part II: fix claims flagged in the final audit
- Only the either-alarm rule beats reactive and preventive in every
  drop-one-test case; single alarms do not (set 2 dropped).
- RUL bound: never catches more failures than acting at the alarm,
  catches fewer at 4-8 h lead, saves at most ~5 h otherwise.
- Threshold sweep: 27 settings, 9 distinct outcomes (AI floor changes
  nothing); "leave one test out" renamed to a drop-one-test check.
- Scope the 2x and 2-day claims to the either-alarm rule; physics is
  late (not silent) on set 1 B3; cross-talk is mostly B3's own signal.
- README notes torch for maintenance_checks.py and library versions.

Co-Authored-By: Claude Opus 5.5 <noreply@anthropic.com>
</commit_message>
<xml_diff>
--- a/predictive_maintenance_part2.pptx
+++ b/predictive_maintenance_part2.pptx
@@ -2227,7 +2227,7 @@
           <a:lstStyle/>
           <a:p>
             <a:r>
-              <a:t>We also tried the textbook predictive-maintenance approach: predict the remaining useful life in hours, then act when it is short. Two attempts, both negative, and we think both are findings. First, gradient boosting with a calibrated safety margin. The honest margin came out at 17 to 59 hours, as wide as the lead time, so it fires right at the alarm and never beats simply acting on the alarm. The reason is in the data: after the alarm, the four bearings lasted 12, 53, 70 and 97 hours, too spread for three training examples. Second, Chronos-2, a large pretrained time-series model: it forecast the vibration levelling off instead of accelerating, and its error was more than twice that of gradient boosting.</a:t>
+              <a:t>We also tried the textbook predictive-maintenance approach: predict the remaining useful life in hours, then act when it is short. Two attempts, both negative, and we think both are findings. First, gradient boosting with a calibrated safety margin. Its margin came out at 17 to 59 hours, as wide as the lead time, so it fires almost right at the alarm: it never catches more failures than simply acting on the alarm, catches fewer with a short lead time, and otherwise saves at most about five hours of bearing life. The reason is in the data: after the alarm, the four bearings lasted 12, 53, 70 and 97 hours, too spread for three training examples. Second, in an exploratory run outside the pipeline, Chronos-2, a large pretrained time-series model: it forecast the vibration levelling off instead of accelerating, and its error was more than twice that of gradient boosting, both scored at forecast points every two hours over the last 100 hours.</a:t>
             </a:r>
           </a:p>
         </p:txBody>
@@ -2523,7 +2523,7 @@
           <a:lstStyle/>
           <a:p>
             <a:r>
-              <a:t>Part I gave us two condition monitors. The physics alarm compares each bearing's vibration energy with its neighbours. The AI alarm is an autoencoder trained only on healthy data: it flags a bearing whose vibration it cannot reconstruct. Neither uses fault labels. The bars show how many hours before failure each one warns. The AI warns about the inner-race fault 71 hours ahead, where physics gives only 12. Physics catches set 3 bearing 3, which the AI misses completely. And the AI never alarmed on a healthy bearing; physics did twice. We checked that the early AI alarm on set 1 bearing 3 is its own impact signal, kurtosis and peaks, and not its failing neighbour bearing 4 heard through the housing. So the two are complementary: use either one's alarm.</a:t>
+              <a:t>Part I gave us two condition monitors. The physics alarm compares each bearing's vibration energy with its neighbours. The AI alarm is an autoencoder trained only on healthy data: it flags a bearing whose vibration it cannot reconstruct. Neither uses fault labels. The bars show how many hours before failure each one warns. The AI warns about the inner-race fault 71 hours ahead, where physics gives only 12. Physics catches set 3 bearing 3, which the AI misses completely. And the AI never alarmed on a healthy bearing; physics did twice. We checked that the early AI alarm on set 1 bearing 3 comes mainly from its own impact signal, kurtosis and peaks, not from its failing neighbour bearing 4 heard through the housing. So the two are complementary: use either one's alarm.</a:t>
             </a:r>
           </a:p>
         </p:txBody>
@@ -2663,7 +2663,7 @@
           <a:lstStyle/>
           <a:p>
             <a:r>
-              <a:t>The result at 24 hours lead time and breakdown cost 10. Reactive: four breakdowns, 4.8 per thousand hours. Preventive, even with the best interval chosen in hindsight: one breakdown and five needless replacements. Physics alone or AI alone: three of four caught. Acting on either alarm catches all four with no breakdowns, at 0.82, about a sixth of reactive and not far from the oracle that knows exactly when each bearing fails.</a:t>
+              <a:t>The result at 24 hours lead time and breakdown cost 10. Reactive: four breakdowns, 4.8 per thousand hours. Preventive, even with the best interval chosen in hindsight: one breakdown and five needless replacements. Physics alone or AI alone: three of four caught. Acting on either alarm catches all four with no breakdowns, at 0.82, about a sixth of reactive; the oracle that knows exactly when each bearing fails would cost 0.48.</a:t>
             </a:r>
           </a:p>
         </p:txBody>
@@ -2733,7 +2733,7 @@
           <a:lstStyle/>
           <a:p>
             <a:r>
-              <a:t>How the answer depends on how expensive a breakdown is, on log scales. When a breakdown costs barely more than a planned repair, nothing beats just running to failure, except the AI alarm with its zero false alarms. From about twice the cost, acting on either alarm is cheaper than reactive and preventive, and its cost stays flat because it has no breakdowns. In most factories a breakdown costs far more than ten times a planned repair. The grey preventive line flattens at the right only because its interval was tuned with hindsight to just before the shortest test ended.</a:t>
+              <a:t>How the answer depends on how expensive a breakdown is, on log scales. When a breakdown costs barely more than a planned repair, nothing beats just running to failure, except the AI alarm with its zero false alarms. From about twice the cost, acting on either alarm is cheaper than reactive and preventive, and its cost stays flat because it has no breakdowns. A breakdown that stops a line often costs far more than a planned repair, but the factor depends on the factory. The grey preventive line flattens at the right only because its interval was tuned with hindsight to just before the shortest test ended.</a:t>
             </a:r>
           </a:p>
         </p:txBody>
@@ -2803,7 +2803,7 @@
           <a:lstStyle/>
           <a:p>
             <a:r>
-              <a:t>How fast does the crew have to act after the alarm? With up to 8 hours, the physics alarm alone catches all four. Between 12 and 48 hours, physics and AI each catch three, and only their combination catches all four: this is where the AI adds value. At 72 hours everything collapses to one of four, because the alarms come 53 to 119 hours before failure. So condition monitoring on these bearings works if replacement happens within about two days of the alarm. Note this is at our default thresholds; the next slide shows what changes when we move them.</a:t>
+              <a:t>How fast does the crew have to act after the alarm? With up to 8 hours, the physics alarm alone catches all four. Between 12 and 48 hours, physics and AI each catch three, and only their combination catches all four: this is where the AI adds value. At 72 hours everything collapses to one of four, because the alarms come 53 to 119 hours before failure. So acting on either alarm catches all four only if replacement happens within about two days of the alarm. Note this is at our default thresholds; the next slide shows what changes when we move them.</a:t>
             </a:r>
           </a:p>
         </p:txBody>
@@ -2873,7 +2873,7 @@
           <a:lstStyle/>
           <a:p>
             <a:r>
-              <a:t>We tested the result against the obvious objections. First, the thresholds were tuned on these same bearings, so we moved all three of them: 27 combinations. Acting on either alarm catches all four failures in every one, at 0.81 to 1.08 per thousand hours. Physics alone catches all four in only 9 of 27. So the AI alarm is insurance: a factory cannot tune its threshold on failures it has not seen. Second, holding out one test at a time, condition-based maintenance always beats reactive and preventive, but which alarm rule is cheapest changes: without set 3, the AI alone wins. Third, if a false alarm costs about four times a planned job or more, the AI alone, with no false alarms, is cheapest. So we claim robustness, not a single winner.</a:t>
+              <a:t>We tested the result against the obvious objections. First, the thresholds were tuned on these same bearings, so we moved all three of them: 27 combinations, 9 distinct outcomes because the AI floor changed nothing. Acting on either alarm catches all four failures in every one, at 0.81 to 1.08 per thousand hours. Physics alone catches all four in only 9 of 27. So the AI alarm is insurance: a factory cannot tune its threshold on failures it has not seen. Second, dropping one test at a time and re-scoring the other two, acting on either alarm always beats reactive and preventive, but the single alarms do not: without set 2 the hindsight-tuned preventive interval beats each of them, and without set 3 the AI alone is cheapest. Third, if a false alarm costs about four times a planned job or more, the AI alone, with no false alarms, is cheapest. So we claim robustness, not a single winner.</a:t>
             </a:r>
           </a:p>
         </p:txBody>
@@ -4298,7 +4298,7 @@
                   <a:srgbClr val="12262B"/>
                 </a:solidFill>
               </a:rPr>
-              <a:t>Never beats “act at the alarm” for lead times 4-48 h</a:t>
+              <a:t>Never catches more than “act at the alarm”; at 4-8 h lead it catches fewer (3 vs 4)</a:t>
             </a:r>
           </a:p>
           <a:p>
@@ -4473,7 +4473,7 @@
                   <a:srgbClr val="5E6E70"/>
                 </a:solidFill>
               </a:rPr>
-              <a:t>RUL error vs gradient boosting (set 2 B1)</a:t>
+              <a:t>RUL error vs gradient boosting (set 2 B1, exploratory run)</a:t>
             </a:r>
           </a:p>
         </p:txBody>
@@ -4866,7 +4866,7 @@
                   <a:srgbClr val="5E6E70"/>
                 </a:solidFill>
               </a:rPr>
-              <a:t>Either alarm catches all 4 in 27/27 threshold settings: AI is insurance</a:t>
+              <a:t>Either alarm catches all 4 in all 27 threshold settings tried: AI is insurance</a:t>
             </a:r>
           </a:p>
         </p:txBody>
@@ -4994,7 +4994,7 @@
                   <a:srgbClr val="5E6E70"/>
                 </a:solidFill>
               </a:rPr>
-              <a:t>Pays above 2× breakdown cost, needs replacement within ~2 days</a:t>
+              <a:t>Either-alarm rule pays above 2×; catches all 4 if replaced within ~2 days</a:t>
             </a:r>
           </a:p>
         </p:txBody>
@@ -5267,6 +5267,21 @@
                 </a:solidFill>
               </a:rPr>
               <a:t>Costs and lead time are assumptions, so we show ranges</a:t>
+            </a:r>
+          </a:p>
+          <a:p>
+            <a:pPr algn="l">
+              <a:spcAft>
+                <a:spcPts val="800"/>
+              </a:spcAft>
+            </a:pPr>
+            <a:r>
+              <a:rPr sz="1500" b="0">
+                <a:solidFill>
+                  <a:srgbClr val="12262B"/>
+                </a:solidFill>
+              </a:rPr>
+              <a:t>Each bearing costed alone; one stop could replace several</a:t>
             </a:r>
           </a:p>
           <a:p>
@@ -6637,7 +6652,7 @@
           <a:lstStyle/>
           <a:p>
             <a:r>
-              <a:t>Two alarms from Part I fail on different bearings</a:t>
+              <a:t>Each alarm is late or silent on a different bearing</a:t>
             </a:r>
           </a:p>
         </p:txBody>
@@ -9546,7 +9561,7 @@
           <a:lstStyle/>
           <a:p>
             <a:r>
-              <a:t>Monitoring pays once a breakdown costs over 2× a repair</a:t>
+              <a:t>Acting on either alarm pays above 2× breakdown cost</a:t>
             </a:r>
           </a:p>
         </p:txBody>
@@ -10121,7 +10136,7 @@
                   <a:srgbClr val="12262B"/>
                 </a:solidFill>
               </a:rPr>
-              <a:t>72 h: alarms come too late for everyone</a:t>
+              <a:t>72 h: each rule catches only 1 of 4</a:t>
             </a:r>
           </a:p>
         </p:txBody>
@@ -10160,7 +10175,7 @@
           <a:lstStyle/>
           <a:p>
             <a:r>
-              <a:t>Robustness: either alarm catches all 4 at every threshold</a:t>
+              <a:t>Robustness: either alarm catches all 4 in every setting tried</a:t>
             </a:r>
           </a:p>
         </p:txBody>
@@ -10331,7 +10346,7 @@
                             <a:srgbClr val="12262B"/>
                           </a:solidFill>
                         </a:rPr>
-                        <a:t>27 threshold settings</a:t>
+                        <a:t>27 threshold settings (lead 24 h, breakdown 10×)</a:t>
                       </a:r>
                     </a:p>
                   </a:txBody>
@@ -10373,7 +10388,7 @@
                             <a:srgbClr val="12262B"/>
                           </a:solidFill>
                         </a:rPr>
-                        <a:t>Physics OR AI: 4/4 in 27/27, cost 0.81-1.08. Physics alone: 4/4 in 9/27</a:t>
+                        <a:t>Physics OR AI: 4/4 in 27/27, cost 0.81-1.08. Physics alone: 4/4 in 9/27. AI floor changed nothing: 9 distinct outcomes</a:t>
                       </a:r>
                     </a:p>
                   </a:txBody>
@@ -10417,7 +10432,7 @@
                             <a:srgbClr val="12262B"/>
                           </a:solidFill>
                         </a:rPr>
-                        <a:t>Leave one test out</a:t>
+                        <a:t>Drop one test, re-score the other two (sensitivity check)</a:t>
                       </a:r>
                     </a:p>
                   </a:txBody>
@@ -10459,7 +10474,7 @@
                             <a:srgbClr val="12262B"/>
                           </a:solidFill>
                         </a:rPr>
-                        <a:t>Condition-based beats reactive (3.9-7.6) and preventive (1.2-3.5) every time; cheapest alarm rule varies</a:t>
+                        <a:t>Physics OR AI beats reactive (3.9-7.6) and preventive (1.2-3.5) every time; single alarms do not (set 2 dropped: preventive 1.21 vs physics 1.91, AI 1.61)</a:t>
                       </a:r>
                     </a:p>
                   </a:txBody>
@@ -10631,7 +10646,7 @@
                             <a:srgbClr val="12262B"/>
                           </a:solidFill>
                         </a:rPr>
-                        <a:t>No: B3's AI alarm is its own impacts (kurtosis, peak), not B4's roller rhythm</a:t>
+                        <a:t>Mostly no: B3's AI alarm is led by its own impacts (kurtosis, peak), not B4's roller rhythm</a:t>
                       </a:r>
                     </a:p>
                   </a:txBody>
@@ -10851,7 +10866,7 @@
                   <a:srgbClr val="F26B4F"/>
                 </a:solidFill>
               </a:rPr>
-              <a:t>Either alarm catches all 4 whatever the threshold</a:t>
+              <a:t>Either alarm catches all 4 in every setting tried</a:t>
             </a:r>
           </a:p>
         </p:txBody>

</xml_diff>

<commit_message>
Part II: add a seven-step replay of test 2 and a replay slide
- bearing_replay.html: Part I (vibration, alarm, Stage B diagnosis) and
  Part II (crew, replacement, why two detectors, cost) as a seven-step
  story of test 2. After the replacement the old bearing is drawn dashed,
  because the real test never replaced it.
- pipeline/replay.py writes the page's data and checks every alarm hour
  and verdict against dl_summary.csv; the page's cost model reproduces
  maintenance_cost_curve.csv and maintenance_lead_sweep.csv.
- Deck: new slide 5 with step 5 of the replay (12 slides); README updated.

Co-Authored-By: Claude Opus 5.5 <noreply@anthropic.com>
</commit_message>
<xml_diff>
--- a/predictive_maintenance_part2.pptx
+++ b/predictive_maintenance_part2.pptx
@@ -15,6 +15,7 @@
     <p:sldId id="276" r:id="rId8"/>
     <p:sldId id="277" r:id="rId7"/>
     <p:sldId id="278" r:id="rId6"/>
+    <p:sldId id="279" r:id="rId5"/>
     <p:sldId id="269" r:id="rId15"/>
   </p:sldIdLst>
   <p:notesMasterIdLst>
@@ -2227,7 +2228,7 @@
           <a:lstStyle/>
           <a:p>
             <a:r>
-              <a:t>We also tried the textbook predictive-maintenance approach: predict the remaining useful life in hours, then act when it is short. Two attempts, both negative, and we think both are findings. First, gradient boosting with a calibrated safety margin. Its margin came out at 17 to 59 hours, as wide as the lead time, so it fires almost right at the alarm: it never catches more failures than simply acting on the alarm, catches fewer with a short lead time, and otherwise saves at most about five hours of bearing life. The reason is in the data: after the alarm, the four bearings lasted 12, 53, 70 and 97 hours, too spread for three training examples. Second, in an exploratory run outside the pipeline, Chronos-2, a large pretrained time-series model: it forecast the vibration levelling off instead of accelerating, and its error was more than twice that of gradient boosting, both scored at forecast points every two hours over the last 100 hours.</a:t>
+              <a:t>We tested the result against the obvious objections. First, the thresholds were tuned on these same bearings, so we moved all three of them: 27 combinations, 9 distinct outcomes because the AI floor changed nothing. Acting on either alarm catches all four failures in every one, at 0.81 to 1.08 per thousand hours. Physics alone catches all four in only 9 of 27. So the AI alarm is insurance: a factory cannot tune its threshold on failures it has not seen. Second, dropping one test at a time and re-scoring the other two, acting on either alarm always beats reactive and preventive, but the single alarms do not: without set 2 the hindsight-tuned preventive interval beats each of them, and without set 3 the AI alone is cheapest. Third, if a false alarm costs about four times a planned job or more, the AI alone, with no false alarms, is cheapest. So we claim robustness, not a single winner.</a:t>
             </a:r>
           </a:p>
         </p:txBody>
@@ -2253,6 +2254,76 @@
 </file>
 
 <file path=ppt/notesSlides/notesSlide11.xml><?xml version="1.0" encoding="utf-8"?>
+<p:notes xmlns:a="http://schemas.openxmlformats.org/drawingml/2006/main" xmlns:p="http://schemas.openxmlformats.org/presentationml/2006/main" xmlns:r="http://schemas.openxmlformats.org/officeDocument/2006/relationships">
+  <p:cSld>
+    <p:spTree>
+      <p:nvGrpSpPr>
+        <p:cNvPr id="1" name=""/>
+        <p:cNvGrpSpPr/>
+        <p:nvPr/>
+      </p:nvGrpSpPr>
+      <p:grpSpPr>
+        <a:xfrm>
+          <a:off x="0" y="0"/>
+          <a:ext cx="0" cy="0"/>
+          <a:chOff x="0" y="0"/>
+          <a:chExt cx="0" cy="0"/>
+        </a:xfrm>
+      </p:grpSpPr>
+      <p:sp>
+        <p:nvSpPr>
+          <p:cNvPr id="2" name="Slide Image Placeholder 1"/>
+          <p:cNvSpPr>
+            <a:spLocks noGrp="1"/>
+          </p:cNvSpPr>
+          <p:nvPr>
+            <p:ph type="sldImg" idx="2"/>
+          </p:nvPr>
+        </p:nvSpPr>
+        <p:spPr/>
+      </p:sp>
+      <p:sp>
+        <p:nvSpPr>
+          <p:cNvPr id="3" name="Notes Placeholder 2"/>
+          <p:cNvSpPr>
+            <a:spLocks noGrp="1"/>
+          </p:cNvSpPr>
+          <p:nvPr>
+            <p:ph type="body" idx="3" sz="quarter"/>
+          </p:nvPr>
+        </p:nvSpPr>
+        <p:spPr/>
+        <p:txBody>
+          <a:bodyPr/>
+          <a:lstStyle/>
+          <a:p>
+            <a:r>
+              <a:t>We also tried the textbook predictive-maintenance approach: predict the remaining useful life in hours, then act when it is short. Two attempts, both negative, and we think both are findings. First, gradient boosting with a calibrated safety margin. Its margin came out at 17 to 59 hours, as wide as the lead time, so it fires almost right at the alarm: it never catches more failures than simply acting on the alarm, catches fewer with a short lead time, and otherwise saves at most about five hours of bearing life. The reason is in the data: after the alarm, the four bearings lasted 12, 53, 70 and 97 hours, too spread for three training examples. Second, in an exploratory run outside the pipeline, Chronos-2, a large pretrained time-series model: it forecast the vibration levelling off instead of accelerating, and its error was more than twice that of gradient boosting, both scored at forecast points every two hours over the last 100 hours.</a:t>
+            </a:r>
+          </a:p>
+        </p:txBody>
+      </p:sp>
+      <p:sp>
+        <p:nvSpPr>
+          <p:cNvPr id="4" name="Slide Number Placeholder 3"/>
+          <p:cNvSpPr>
+            <a:spLocks noGrp="1"/>
+          </p:cNvSpPr>
+          <p:nvPr>
+            <p:ph type="sldNum" idx="5" sz="quarter"/>
+          </p:nvPr>
+        </p:nvSpPr>
+        <p:spPr/>
+      </p:sp>
+    </p:spTree>
+  </p:cSld>
+  <p:clrMapOvr>
+    <a:masterClrMapping/>
+  </p:clrMapOvr>
+</p:notes>
+</file>
+
+<file path=ppt/notesSlides/notesSlide12.xml><?xml version="1.0" encoding="utf-8"?>
 <p:notes xmlns:a="http://schemas.openxmlformats.org/drawingml/2006/main" xmlns:p="http://schemas.openxmlformats.org/presentationml/2006/main" xmlns:r="http://schemas.openxmlformats.org/officeDocument/2006/relationships">
   <p:cSld>
     <p:spTree>
@@ -2663,7 +2734,7 @@
           <a:lstStyle/>
           <a:p>
             <a:r>
-              <a:t>The result at 24 hours lead time and breakdown cost 10. Reactive: four breakdowns, 4.8 per thousand hours. Preventive, even with the best interval chosen in hindsight: one breakdown and five needless replacements. Physics alone or AI alone: three of four caught. Acting on either alarm catches all four with no breakdowns, at 0.82, about a sixth of reactive; the oracle that knows exactly when each bearing fails would cost 0.48.</a:t>
+              <a:t>This is step 5 of our replay page, for test 2. Bearing 1's vibration starts to rise around hour 90. Part I's physics alarm fires at hour 94, the AI alarm agrees at hour 110, and Stage B names an outer-race fault, which is what actually failed. Then Part II takes over: the work order goes out at the first alarm, the crew needs 24 hours, so bearing 1 is replaced at hour 118, 45.5 hours before it broke in the real test. Why does the grey line keep rising? Because in the real NASA experiment nobody replaced the bearing: the test ran until it broke. The grey part is the breakdown our rule avoids. A planned replacement costs 1, a breakdown 10. The next slide is the same bookkeeping for all 12 bearings. The live replay, bearing_replay.html in our repository, walks through all seven steps.</a:t>
             </a:r>
           </a:p>
         </p:txBody>
@@ -2733,7 +2804,7 @@
           <a:lstStyle/>
           <a:p>
             <a:r>
-              <a:t>How the answer depends on how expensive a breakdown is, on log scales. When a breakdown costs barely more than a planned repair, nothing beats just running to failure, except the AI alarm with its zero false alarms. From about twice the cost, acting on either alarm is cheaper than reactive and preventive, and its cost stays flat because it has no breakdowns. A breakdown that stops a line often costs far more than a planned repair, but the factor depends on the factory. The grey preventive line flattens at the right only because its interval was tuned with hindsight to just before the shortest test ended.</a:t>
+              <a:t>The result at 24 hours lead time and breakdown cost 10. Reactive: four breakdowns, 4.8 per thousand hours. Preventive, even with the best interval chosen in hindsight: one breakdown and five needless replacements. Physics alone or AI alone: three of four caught. Acting on either alarm catches all four with no breakdowns, at 0.82, about a sixth of reactive; the oracle that knows exactly when each bearing fails would cost 0.48.</a:t>
             </a:r>
           </a:p>
         </p:txBody>
@@ -2803,7 +2874,7 @@
           <a:lstStyle/>
           <a:p>
             <a:r>
-              <a:t>How fast does the crew have to act after the alarm? With up to 8 hours, the physics alarm alone catches all four. Between 12 and 48 hours, physics and AI each catch three, and only their combination catches all four: this is where the AI adds value. At 72 hours everything collapses to one of four, because the alarms come 53 to 119 hours before failure. So acting on either alarm catches all four only if replacement happens within about two days of the alarm. Note this is at our default thresholds; the next slide shows what changes when we move them.</a:t>
+              <a:t>How the answer depends on how expensive a breakdown is, on log scales. When a breakdown costs barely more than a planned repair, nothing beats just running to failure, except the AI alarm with its zero false alarms. From about twice the cost, acting on either alarm is cheaper than reactive and preventive, and its cost stays flat because it has no breakdowns. A breakdown that stops a line often costs far more than a planned repair, but the factor depends on the factory. The grey preventive line flattens at the right only because its interval was tuned with hindsight to just before the shortest test ended.</a:t>
             </a:r>
           </a:p>
         </p:txBody>
@@ -2873,7 +2944,7 @@
           <a:lstStyle/>
           <a:p>
             <a:r>
-              <a:t>We tested the result against the obvious objections. First, the thresholds were tuned on these same bearings, so we moved all three of them: 27 combinations, 9 distinct outcomes because the AI floor changed nothing. Acting on either alarm catches all four failures in every one, at 0.81 to 1.08 per thousand hours. Physics alone catches all four in only 9 of 27. So the AI alarm is insurance: a factory cannot tune its threshold on failures it has not seen. Second, dropping one test at a time and re-scoring the other two, acting on either alarm always beats reactive and preventive, but the single alarms do not: without set 2 the hindsight-tuned preventive interval beats each of them, and without set 3 the AI alone is cheapest. Third, if a false alarm costs about four times a planned job or more, the AI alone, with no false alarms, is cheapest. So we claim robustness, not a single winner.</a:t>
+              <a:t>How fast does the crew have to act after the alarm? With up to 8 hours, the physics alarm alone catches all four. Between 12 and 48 hours, physics and AI each catch three, and only their combination catches all four: this is where the AI adds value. At 72 hours everything collapses to one of four, because the alarms come 53 to 119 hours before failure. So acting on either alarm catches all four only if replacement happens within about two days of the alarm. Note this is at our default thresholds; the next slide shows what changes when we move them.</a:t>
             </a:r>
           </a:p>
         </p:txBody>
@@ -4055,7 +4126,7 @@
           <a:lstStyle/>
           <a:p>
             <a:r>
-              <a:t>What didn’t work: predicting the hours left</a:t>
+              <a:t>Robustness: either alarm catches all 4 in every setting tried</a:t>
             </a:r>
           </a:p>
         </p:txBody>
@@ -4105,16 +4176,548 @@
           </a:p>
         </p:txBody>
       </p:sp>
-      <p:sp>
-        <p:nvSpPr>
-          <p:cNvPr id="26" name="negative Calibrated RUL bound"/>
+      <p:graphicFrame>
+        <p:nvGraphicFramePr>
+          <p:cNvPr id="26" name="Table 25"/>
+          <p:cNvGraphicFramePr>
+            <a:graphicFrameLocks noGrp="1"/>
+          </p:cNvGraphicFramePr>
+          <p:nvPr/>
+        </p:nvGraphicFramePr>
+        <p:xfrm>
+          <a:off x="548640" y="1371600"/>
+          <a:ext cx="8138160" cy="3886200"/>
+        </p:xfrm>
+        <a:graphic>
+          <a:graphicData uri="http://schemas.openxmlformats.org/drawingml/2006/table">
+            <a:tbl>
+              <a:tblPr firstRow="1">
+                <a:tableStyleId>{5C22544A-7EE6-4342-B048-85BDC9FD1C3A}</a:tableStyleId>
+              </a:tblPr>
+              <a:tblGrid>
+                <a:gridCol w="2651760"/>
+                <a:gridCol w="5486400"/>
+              </a:tblGrid>
+              <a:tr h="777240">
+                <a:tc>
+                  <a:txBody>
+                    <a:bodyPr wrap="square"/>
+                    <a:lstStyle/>
+                    <a:p>
+                      <a:pPr algn="l"/>
+                      <a:r>
+                        <a:rPr sz="1400" b="1">
+                          <a:solidFill>
+                            <a:srgbClr val="FFFFFF"/>
+                          </a:solidFill>
+                        </a:rPr>
+                        <a:t>Check</a:t>
+                      </a:r>
+                    </a:p>
+                  </a:txBody>
+                  <a:tcPr anchor="ctr" marL="73152" marR="73152">
+                    <a:lnL w="9525">
+                      <a:solidFill>
+                        <a:srgbClr val="D3E2E0"/>
+                      </a:solidFill>
+                    </a:lnL>
+                    <a:lnR w="9525">
+                      <a:solidFill>
+                        <a:srgbClr val="D3E2E0"/>
+                      </a:solidFill>
+                    </a:lnR>
+                    <a:lnT w="9525">
+                      <a:solidFill>
+                        <a:srgbClr val="D3E2E0"/>
+                      </a:solidFill>
+                    </a:lnT>
+                    <a:lnB w="9525">
+                      <a:solidFill>
+                        <a:srgbClr val="D3E2E0"/>
+                      </a:solidFill>
+                    </a:lnB>
+                    <a:solidFill>
+                      <a:srgbClr val="0F4C5C"/>
+                    </a:solidFill>
+                  </a:tcPr>
+                </a:tc>
+                <a:tc>
+                  <a:txBody>
+                    <a:bodyPr wrap="square"/>
+                    <a:lstStyle/>
+                    <a:p>
+                      <a:pPr algn="l"/>
+                      <a:r>
+                        <a:rPr sz="1400" b="1">
+                          <a:solidFill>
+                            <a:srgbClr val="FFFFFF"/>
+                          </a:solidFill>
+                        </a:rPr>
+                        <a:t>Result</a:t>
+                      </a:r>
+                    </a:p>
+                  </a:txBody>
+                  <a:tcPr anchor="ctr" marL="73152" marR="73152">
+                    <a:lnL w="9525">
+                      <a:solidFill>
+                        <a:srgbClr val="D3E2E0"/>
+                      </a:solidFill>
+                    </a:lnL>
+                    <a:lnR w="9525">
+                      <a:solidFill>
+                        <a:srgbClr val="D3E2E0"/>
+                      </a:solidFill>
+                    </a:lnR>
+                    <a:lnT w="9525">
+                      <a:solidFill>
+                        <a:srgbClr val="D3E2E0"/>
+                      </a:solidFill>
+                    </a:lnT>
+                    <a:lnB w="9525">
+                      <a:solidFill>
+                        <a:srgbClr val="D3E2E0"/>
+                      </a:solidFill>
+                    </a:lnB>
+                    <a:solidFill>
+                      <a:srgbClr val="0F4C5C"/>
+                    </a:solidFill>
+                  </a:tcPr>
+                </a:tc>
+              </a:tr>
+              <a:tr h="777240">
+                <a:tc>
+                  <a:txBody>
+                    <a:bodyPr wrap="square"/>
+                    <a:lstStyle/>
+                    <a:p>
+                      <a:pPr algn="l"/>
+                      <a:r>
+                        <a:rPr sz="1500" b="0">
+                          <a:solidFill>
+                            <a:srgbClr val="12262B"/>
+                          </a:solidFill>
+                        </a:rPr>
+                        <a:t>27 threshold settings (lead 24 h, breakdown 10×)</a:t>
+                      </a:r>
+                    </a:p>
+                  </a:txBody>
+                  <a:tcPr anchor="ctr" marL="73152" marR="73152">
+                    <a:lnL w="9525">
+                      <a:solidFill>
+                        <a:srgbClr val="D3E2E0"/>
+                      </a:solidFill>
+                    </a:lnL>
+                    <a:lnR w="9525">
+                      <a:solidFill>
+                        <a:srgbClr val="D3E2E0"/>
+                      </a:solidFill>
+                    </a:lnR>
+                    <a:lnT w="9525">
+                      <a:solidFill>
+                        <a:srgbClr val="D3E2E0"/>
+                      </a:solidFill>
+                    </a:lnT>
+                    <a:lnB w="9525">
+                      <a:solidFill>
+                        <a:srgbClr val="D3E2E0"/>
+                      </a:solidFill>
+                    </a:lnB>
+                    <a:solidFill>
+                      <a:srgbClr val="FFFFFF"/>
+                    </a:solidFill>
+                  </a:tcPr>
+                </a:tc>
+                <a:tc>
+                  <a:txBody>
+                    <a:bodyPr wrap="square"/>
+                    <a:lstStyle/>
+                    <a:p>
+                      <a:pPr algn="l"/>
+                      <a:r>
+                        <a:rPr sz="1500" b="0">
+                          <a:solidFill>
+                            <a:srgbClr val="12262B"/>
+                          </a:solidFill>
+                        </a:rPr>
+                        <a:t>Physics OR AI: 4/4 in 27/27, cost 0.81-1.08. Physics alone: 4/4 in 9/27. AI floor changed nothing: 9 distinct outcomes</a:t>
+                      </a:r>
+                    </a:p>
+                  </a:txBody>
+                  <a:tcPr anchor="ctr" marL="73152" marR="73152">
+                    <a:lnL w="9525">
+                      <a:solidFill>
+                        <a:srgbClr val="D3E2E0"/>
+                      </a:solidFill>
+                    </a:lnL>
+                    <a:lnR w="9525">
+                      <a:solidFill>
+                        <a:srgbClr val="D3E2E0"/>
+                      </a:solidFill>
+                    </a:lnR>
+                    <a:lnT w="9525">
+                      <a:solidFill>
+                        <a:srgbClr val="D3E2E0"/>
+                      </a:solidFill>
+                    </a:lnT>
+                    <a:lnB w="9525">
+                      <a:solidFill>
+                        <a:srgbClr val="D3E2E0"/>
+                      </a:solidFill>
+                    </a:lnB>
+                    <a:solidFill>
+                      <a:srgbClr val="FFFFFF"/>
+                    </a:solidFill>
+                  </a:tcPr>
+                </a:tc>
+              </a:tr>
+              <a:tr h="777240">
+                <a:tc>
+                  <a:txBody>
+                    <a:bodyPr wrap="square"/>
+                    <a:lstStyle/>
+                    <a:p>
+                      <a:pPr algn="l"/>
+                      <a:r>
+                        <a:rPr sz="1500" b="0">
+                          <a:solidFill>
+                            <a:srgbClr val="12262B"/>
+                          </a:solidFill>
+                        </a:rPr>
+                        <a:t>Drop one test, re-score the other two (sensitivity check)</a:t>
+                      </a:r>
+                    </a:p>
+                  </a:txBody>
+                  <a:tcPr anchor="ctr" marL="73152" marR="73152">
+                    <a:lnL w="9525">
+                      <a:solidFill>
+                        <a:srgbClr val="D3E2E0"/>
+                      </a:solidFill>
+                    </a:lnL>
+                    <a:lnR w="9525">
+                      <a:solidFill>
+                        <a:srgbClr val="D3E2E0"/>
+                      </a:solidFill>
+                    </a:lnR>
+                    <a:lnT w="9525">
+                      <a:solidFill>
+                        <a:srgbClr val="D3E2E0"/>
+                      </a:solidFill>
+                    </a:lnT>
+                    <a:lnB w="9525">
+                      <a:solidFill>
+                        <a:srgbClr val="D3E2E0"/>
+                      </a:solidFill>
+                    </a:lnB>
+                    <a:solidFill>
+                      <a:srgbClr val="FFFFFF"/>
+                    </a:solidFill>
+                  </a:tcPr>
+                </a:tc>
+                <a:tc>
+                  <a:txBody>
+                    <a:bodyPr wrap="square"/>
+                    <a:lstStyle/>
+                    <a:p>
+                      <a:pPr algn="l"/>
+                      <a:r>
+                        <a:rPr sz="1500" b="0">
+                          <a:solidFill>
+                            <a:srgbClr val="12262B"/>
+                          </a:solidFill>
+                        </a:rPr>
+                        <a:t>Physics OR AI beats reactive (3.9-7.6) and preventive (1.2-3.5) every time; single alarms do not (set 2 dropped: preventive 1.21 vs physics 1.91, AI 1.61)</a:t>
+                      </a:r>
+                    </a:p>
+                  </a:txBody>
+                  <a:tcPr anchor="ctr" marL="73152" marR="73152">
+                    <a:lnL w="9525">
+                      <a:solidFill>
+                        <a:srgbClr val="D3E2E0"/>
+                      </a:solidFill>
+                    </a:lnL>
+                    <a:lnR w="9525">
+                      <a:solidFill>
+                        <a:srgbClr val="D3E2E0"/>
+                      </a:solidFill>
+                    </a:lnR>
+                    <a:lnT w="9525">
+                      <a:solidFill>
+                        <a:srgbClr val="D3E2E0"/>
+                      </a:solidFill>
+                    </a:lnT>
+                    <a:lnB w="9525">
+                      <a:solidFill>
+                        <a:srgbClr val="D3E2E0"/>
+                      </a:solidFill>
+                    </a:lnB>
+                    <a:solidFill>
+                      <a:srgbClr val="FFFFFF"/>
+                    </a:solidFill>
+                  </a:tcPr>
+                </a:tc>
+              </a:tr>
+              <a:tr h="777240">
+                <a:tc>
+                  <a:txBody>
+                    <a:bodyPr wrap="square"/>
+                    <a:lstStyle/>
+                    <a:p>
+                      <a:pPr algn="l"/>
+                      <a:r>
+                        <a:rPr sz="1500" b="0">
+                          <a:solidFill>
+                            <a:srgbClr val="12262B"/>
+                          </a:solidFill>
+                        </a:rPr>
+                        <a:t>False alarm 5× a planned job</a:t>
+                      </a:r>
+                    </a:p>
+                  </a:txBody>
+                  <a:tcPr anchor="ctr" marL="73152" marR="73152">
+                    <a:lnL w="9525">
+                      <a:solidFill>
+                        <a:srgbClr val="D3E2E0"/>
+                      </a:solidFill>
+                    </a:lnL>
+                    <a:lnR w="9525">
+                      <a:solidFill>
+                        <a:srgbClr val="D3E2E0"/>
+                      </a:solidFill>
+                    </a:lnR>
+                    <a:lnT w="9525">
+                      <a:solidFill>
+                        <a:srgbClr val="D3E2E0"/>
+                      </a:solidFill>
+                    </a:lnT>
+                    <a:lnB w="9525">
+                      <a:solidFill>
+                        <a:srgbClr val="D3E2E0"/>
+                      </a:solidFill>
+                    </a:lnB>
+                    <a:solidFill>
+                      <a:srgbClr val="FFFFFF"/>
+                    </a:solidFill>
+                  </a:tcPr>
+                </a:tc>
+                <a:tc>
+                  <a:txBody>
+                    <a:bodyPr wrap="square"/>
+                    <a:lstStyle/>
+                    <a:p>
+                      <a:pPr algn="l"/>
+                      <a:r>
+                        <a:rPr sz="1500" b="0">
+                          <a:solidFill>
+                            <a:srgbClr val="12262B"/>
+                          </a:solidFill>
+                        </a:rPr>
+                        <a:t>AI alone cheapest (1.61 vs 1.91 for either alarm)</a:t>
+                      </a:r>
+                    </a:p>
+                  </a:txBody>
+                  <a:tcPr anchor="ctr" marL="73152" marR="73152">
+                    <a:lnL w="9525">
+                      <a:solidFill>
+                        <a:srgbClr val="D3E2E0"/>
+                      </a:solidFill>
+                    </a:lnL>
+                    <a:lnR w="9525">
+                      <a:solidFill>
+                        <a:srgbClr val="D3E2E0"/>
+                      </a:solidFill>
+                    </a:lnR>
+                    <a:lnT w="9525">
+                      <a:solidFill>
+                        <a:srgbClr val="D3E2E0"/>
+                      </a:solidFill>
+                    </a:lnT>
+                    <a:lnB w="9525">
+                      <a:solidFill>
+                        <a:srgbClr val="D3E2E0"/>
+                      </a:solidFill>
+                    </a:lnB>
+                    <a:solidFill>
+                      <a:srgbClr val="FFFFFF"/>
+                    </a:solidFill>
+                  </a:tcPr>
+                </a:tc>
+              </a:tr>
+              <a:tr h="777240">
+                <a:tc>
+                  <a:txBody>
+                    <a:bodyPr wrap="square"/>
+                    <a:lstStyle/>
+                    <a:p>
+                      <a:pPr algn="l"/>
+                      <a:r>
+                        <a:rPr sz="1500" b="0">
+                          <a:solidFill>
+                            <a:srgbClr val="12262B"/>
+                          </a:solidFill>
+                        </a:rPr>
+                        <a:t>Set 1 B3 cross-talk from B4?</a:t>
+                      </a:r>
+                    </a:p>
+                  </a:txBody>
+                  <a:tcPr anchor="ctr" marL="73152" marR="73152">
+                    <a:lnL w="9525">
+                      <a:solidFill>
+                        <a:srgbClr val="D3E2E0"/>
+                      </a:solidFill>
+                    </a:lnL>
+                    <a:lnR w="9525">
+                      <a:solidFill>
+                        <a:srgbClr val="D3E2E0"/>
+                      </a:solidFill>
+                    </a:lnR>
+                    <a:lnT w="9525">
+                      <a:solidFill>
+                        <a:srgbClr val="D3E2E0"/>
+                      </a:solidFill>
+                    </a:lnT>
+                    <a:lnB w="9525">
+                      <a:solidFill>
+                        <a:srgbClr val="D3E2E0"/>
+                      </a:solidFill>
+                    </a:lnB>
+                    <a:solidFill>
+                      <a:srgbClr val="FFFFFF"/>
+                    </a:solidFill>
+                  </a:tcPr>
+                </a:tc>
+                <a:tc>
+                  <a:txBody>
+                    <a:bodyPr wrap="square"/>
+                    <a:lstStyle/>
+                    <a:p>
+                      <a:pPr algn="l"/>
+                      <a:r>
+                        <a:rPr sz="1500" b="0">
+                          <a:solidFill>
+                            <a:srgbClr val="12262B"/>
+                          </a:solidFill>
+                        </a:rPr>
+                        <a:t>Mostly no: B3's AI alarm is led by its own impacts (kurtosis, peak), not B4's roller rhythm</a:t>
+                      </a:r>
+                    </a:p>
+                  </a:txBody>
+                  <a:tcPr anchor="ctr" marL="73152" marR="73152">
+                    <a:lnL w="9525">
+                      <a:solidFill>
+                        <a:srgbClr val="D3E2E0"/>
+                      </a:solidFill>
+                    </a:lnL>
+                    <a:lnR w="9525">
+                      <a:solidFill>
+                        <a:srgbClr val="D3E2E0"/>
+                      </a:solidFill>
+                    </a:lnR>
+                    <a:lnT w="9525">
+                      <a:solidFill>
+                        <a:srgbClr val="D3E2E0"/>
+                      </a:solidFill>
+                    </a:lnT>
+                    <a:lnB w="9525">
+                      <a:solidFill>
+                        <a:srgbClr val="D3E2E0"/>
+                      </a:solidFill>
+                    </a:lnB>
+                    <a:solidFill>
+                      <a:srgbClr val="FFFFFF"/>
+                    </a:solidFill>
+                  </a:tcPr>
+                </a:tc>
+              </a:tr>
+            </a:tbl>
+          </a:graphicData>
+        </a:graphic>
+      </p:graphicFrame>
+      <p:sp>
+        <p:nvSpPr>
+          <p:cNvPr id="27" name="stat 27 / 27"/>
+          <p:cNvSpPr txBox="1"/>
+          <p:nvPr/>
+        </p:nvSpPr>
+        <p:spPr>
+          <a:xfrm>
+            <a:off x="9052560" y="1280160"/>
+            <a:ext cx="2560320" cy="777240"/>
+          </a:xfrm>
+          <a:prstGeom prst="rect">
+            <a:avLst/>
+          </a:prstGeom>
+          <a:noFill/>
+        </p:spPr>
+        <p:txBody>
+          <a:bodyPr wrap="square" anchor="t" lIns="0" rIns="0" tIns="0" bIns="0">
+            <a:spAutoFit/>
+          </a:bodyPr>
+          <a:lstStyle/>
+          <a:p>
+            <a:pPr algn="l">
+              <a:spcAft>
+                <a:spcPts val="600"/>
+              </a:spcAft>
+            </a:pPr>
+            <a:r>
+              <a:rPr sz="4400" b="1">
+                <a:solidFill>
+                  <a:srgbClr val="3E9B5F"/>
+                </a:solidFill>
+              </a:rPr>
+              <a:t>27 / 27</a:t>
+            </a:r>
+          </a:p>
+        </p:txBody>
+      </p:sp>
+      <p:sp>
+        <p:nvSpPr>
+          <p:cNvPr id="28" name="TextBox 27"/>
+          <p:cNvSpPr txBox="1"/>
+          <p:nvPr/>
+        </p:nvSpPr>
+        <p:spPr>
+          <a:xfrm>
+            <a:off x="9052560" y="2057400"/>
+            <a:ext cx="2560320" cy="640080"/>
+          </a:xfrm>
+          <a:prstGeom prst="rect">
+            <a:avLst/>
+          </a:prstGeom>
+          <a:noFill/>
+        </p:spPr>
+        <p:txBody>
+          <a:bodyPr wrap="square" anchor="t" lIns="0" rIns="0" tIns="0" bIns="0">
+            <a:spAutoFit/>
+          </a:bodyPr>
+          <a:lstStyle/>
+          <a:p>
+            <a:pPr algn="l">
+              <a:spcAft>
+                <a:spcPts val="600"/>
+              </a:spcAft>
+            </a:pPr>
+            <a:r>
+              <a:rPr sz="1500" b="0">
+                <a:solidFill>
+                  <a:srgbClr val="5E6E70"/>
+                </a:solidFill>
+              </a:rPr>
+              <a:t>threshold settings where either alarm catches all 4</a:t>
+            </a:r>
+          </a:p>
+        </p:txBody>
+      </p:sp>
+      <p:sp>
+        <p:nvSpPr>
+          <p:cNvPr id="29" name="insurance note"/>
           <p:cNvSpPr/>
           <p:nvPr/>
         </p:nvSpPr>
         <p:spPr>
           <a:xfrm>
-            <a:off x="548640" y="1371600"/>
-            <a:ext cx="5394960" cy="4023360"/>
+            <a:off x="9052560" y="3017520"/>
+            <a:ext cx="2560320" cy="2651760"/>
           </a:xfrm>
           <a:prstGeom prst="roundRect">
             <a:avLst>
@@ -4153,14 +4756,14 @@
       </p:sp>
       <p:sp>
         <p:nvSpPr>
-          <p:cNvPr id="27" name="TextBox 26"/>
+          <p:cNvPr id="30" name="TextBox 29"/>
           <p:cNvSpPr txBox="1"/>
           <p:nvPr/>
         </p:nvSpPr>
         <p:spPr>
           <a:xfrm>
-            <a:off x="868680" y="1600200"/>
-            <a:ext cx="4754880" cy="457200"/>
+            <a:off x="9235440" y="3154680"/>
+            <a:ext cx="2194560" cy="2468880"/>
           </a:xfrm>
           <a:prstGeom prst="rect">
             <a:avLst/>
@@ -4179,37 +4782,14 @@
               </a:spcAft>
             </a:pPr>
             <a:r>
-              <a:rPr sz="2200" b="1">
+              <a:rPr sz="1800" b="1">
                 <a:solidFill>
                   <a:srgbClr val="12262B"/>
                 </a:solidFill>
               </a:rPr>
-              <a:t>Calibrated RUL bound</a:t>
-            </a:r>
-          </a:p>
-        </p:txBody>
-      </p:sp>
-      <p:sp>
-        <p:nvSpPr>
-          <p:cNvPr id="28" name="TextBox 27"/>
-          <p:cNvSpPr txBox="1"/>
-          <p:nvPr/>
-        </p:nvSpPr>
-        <p:spPr>
-          <a:xfrm>
-            <a:off x="868680" y="2194560"/>
-            <a:ext cx="4754880" cy="822960"/>
-          </a:xfrm>
-          <a:prstGeom prst="rect">
-            <a:avLst/>
-          </a:prstGeom>
-          <a:noFill/>
-        </p:spPr>
-        <p:txBody>
-          <a:bodyPr wrap="square" anchor="t" lIns="0" rIns="0" tIns="0" bIns="0">
-            <a:spAutoFit/>
-          </a:bodyPr>
-          <a:lstStyle/>
+              <a:t>AI as insurance</a:t>
+            </a:r>
+          </a:p>
           <a:p>
             <a:pPr algn="l">
               <a:spcAft>
@@ -4217,37 +4797,14 @@
               </a:spcAft>
             </a:pPr>
             <a:r>
-              <a:rPr sz="4400" b="1">
-                <a:solidFill>
-                  <a:srgbClr val="D64545"/>
+              <a:rPr sz="1500" b="0">
+                <a:solidFill>
+                  <a:srgbClr val="12262B"/>
                 </a:solidFill>
               </a:rPr>
-              <a:t>17-59 h</a:t>
-            </a:r>
-          </a:p>
-        </p:txBody>
-      </p:sp>
-      <p:sp>
-        <p:nvSpPr>
-          <p:cNvPr id="29" name="TextBox 28"/>
-          <p:cNvSpPr txBox="1"/>
-          <p:nvPr/>
-        </p:nvSpPr>
-        <p:spPr>
-          <a:xfrm>
-            <a:off x="868680" y="3017520"/>
-            <a:ext cx="4754880" cy="457200"/>
-          </a:xfrm>
-          <a:prstGeom prst="rect">
-            <a:avLst/>
-          </a:prstGeom>
-          <a:noFill/>
-        </p:spPr>
-        <p:txBody>
-          <a:bodyPr wrap="square" anchor="t" lIns="0" rIns="0" tIns="0" bIns="0">
-            <a:spAutoFit/>
-          </a:bodyPr>
-          <a:lstStyle/>
+              <a:t>Physics alone needs a lucky threshold to catch all 4</a:t>
+            </a:r>
+          </a:p>
           <a:p>
             <a:pPr algn="l">
               <a:spcAft>
@@ -4255,78 +4812,109 @@
               </a:spcAft>
             </a:pPr>
             <a:r>
-              <a:rPr sz="1500" b="0">
-                <a:solidFill>
-                  <a:srgbClr val="5E6E70"/>
+              <a:rPr sz="1500" b="1">
+                <a:solidFill>
+                  <a:srgbClr val="F26B4F"/>
                 </a:solidFill>
               </a:rPr>
-              <a:t>safety margin, as wide as the lead time</a:t>
-            </a:r>
-          </a:p>
-        </p:txBody>
-      </p:sp>
-      <p:sp>
-        <p:nvSpPr>
-          <p:cNvPr id="30" name="TextBox 29"/>
-          <p:cNvSpPr txBox="1"/>
-          <p:nvPr/>
-        </p:nvSpPr>
-        <p:spPr>
-          <a:xfrm>
-            <a:off x="868680" y="3749039"/>
-            <a:ext cx="4754880" cy="2194560"/>
+              <a:t>Either alarm catches all 4 in every setting tried</a:t>
+            </a:r>
+          </a:p>
+        </p:txBody>
+      </p:sp>
+    </p:spTree>
+  </p:cSld>
+  <p:clrMapOvr>
+    <a:masterClrMapping/>
+  </p:clrMapOvr>
+</p:sld>
+</file>
+
+<file path=ppt/slides/slide11.xml><?xml version="1.0" encoding="utf-8"?>
+<p:sld xmlns:a="http://schemas.openxmlformats.org/drawingml/2006/main" xmlns:p="http://schemas.openxmlformats.org/presentationml/2006/main" xmlns:r="http://schemas.openxmlformats.org/officeDocument/2006/relationships">
+  <p:cSld>
+    <p:spTree>
+      <p:nvGrpSpPr>
+        <p:cNvPr id="1" name=""/>
+        <p:cNvGrpSpPr/>
+        <p:nvPr/>
+      </p:nvGrpSpPr>
+      <p:grpSpPr/>
+      <p:sp>
+        <p:nvSpPr>
+          <p:cNvPr id="2" name="Title 1"/>
+          <p:cNvSpPr>
+            <a:spLocks noGrp="1"/>
+          </p:cNvSpPr>
+          <p:nvPr>
+            <p:ph type="title" idx="100"/>
+          </p:nvPr>
+        </p:nvSpPr>
+        <p:spPr/>
+        <p:txBody>
+          <a:bodyPr/>
+          <a:lstStyle/>
+          <a:p>
+            <a:r>
+              <a:t>What didn’t work: predicting the hours left</a:t>
+            </a:r>
+          </a:p>
+        </p:txBody>
+      </p:sp>
+      <p:sp>
+        <p:nvSpPr>
+          <p:cNvPr id="25" name="Slide Number Placeholder 0"/>
+          <p:cNvSpPr>
+            <a:spLocks noGrp="1"/>
+          </p:cNvSpPr>
+          <p:nvPr>
+            <p:ph type="sldNum" sz="quarter" idx="4294967295"/>
+          </p:nvPr>
+        </p:nvSpPr>
+        <p:spPr>
+          <a:xfrm>
+            <a:off x="11155680" y="6400800"/>
+            <a:ext cx="457200" cy="274320"/>
           </a:xfrm>
           <a:prstGeom prst="rect">
             <a:avLst/>
           </a:prstGeom>
-          <a:noFill/>
-        </p:spPr>
-        <p:txBody>
-          <a:bodyPr wrap="square" anchor="t" lIns="0" rIns="0" tIns="0" bIns="0">
-            <a:spAutoFit/>
-          </a:bodyPr>
-          <a:lstStyle/>
-          <a:p>
-            <a:pPr algn="l">
-              <a:spcAft>
-                <a:spcPts val="1000"/>
-              </a:spcAft>
-            </a:pPr>
-            <a:r>
-              <a:rPr sz="1600" b="0">
-                <a:solidFill>
-                  <a:srgbClr val="12262B"/>
-                </a:solidFill>
-              </a:rPr>
-              <a:t>Never catches more than “act at the alarm”; at 4-8 h lead it catches fewer (3 vs 4)</a:t>
-            </a:r>
-          </a:p>
-          <a:p>
-            <a:pPr algn="l">
-              <a:spcAft>
-                <a:spcPts val="1000"/>
-              </a:spcAft>
-            </a:pPr>
-            <a:r>
-              <a:rPr sz="1600" b="0">
-                <a:solidFill>
-                  <a:srgbClr val="12262B"/>
-                </a:solidFill>
-              </a:rPr>
-              <a:t>After the alarm the bearings lasted 12, 53, 70, 97 h: too spread to learn from 3 examples</a:t>
-            </a:r>
-          </a:p>
-        </p:txBody>
-      </p:sp>
-      <p:sp>
-        <p:nvSpPr>
-          <p:cNvPr id="31" name="negative Foundation model (Chronos-2)"/>
+          <a:extLst>
+            <a:ext uri="{C572A759-6A51-4108-AA02-DFA0A04FC94B}">
+              <ma14:wrappingTextBoxFlag xmlns:ma14="http://schemas.microsoft.com/office/mac/drawingml/2011/main" val="0"/>
+            </a:ext>
+          </a:extLst>
+        </p:spPr>
+        <p:txBody>
+          <a:bodyPr/>
+          <a:lstStyle>
+            <a:lvl1pPr>
+              <a:defRPr sz="1000">
+                <a:solidFill>
+                  <a:srgbClr val="8A9A9B"/>
+                </a:solidFill>
+              </a:defRPr>
+            </a:lvl1pPr>
+          </a:lstStyle>
+          <a:p>
+            <a:pPr algn="r"/>
+            <a:fld id="{F7021451-1387-4CA6-816F-3879F97B5CBC}" type="slidenum">
+              <a:rPr b="0" lang="en-US"/>
+              <a:t>2</a:t>
+            </a:fld>
+            <a:endParaRPr lang="en-US"/>
+          </a:p>
+        </p:txBody>
+      </p:sp>
+      <p:sp>
+        <p:nvSpPr>
+          <p:cNvPr id="26" name="negative Calibrated RUL bound"/>
           <p:cNvSpPr/>
           <p:nvPr/>
         </p:nvSpPr>
         <p:spPr>
           <a:xfrm>
-            <a:off x="6217920" y="1371600"/>
+            <a:off x="548640" y="1371600"/>
             <a:ext cx="5394960" cy="4023360"/>
           </a:xfrm>
           <a:prstGeom prst="roundRect">
@@ -4366,6 +4954,219 @@
       </p:sp>
       <p:sp>
         <p:nvSpPr>
+          <p:cNvPr id="27" name="TextBox 26"/>
+          <p:cNvSpPr txBox="1"/>
+          <p:nvPr/>
+        </p:nvSpPr>
+        <p:spPr>
+          <a:xfrm>
+            <a:off x="868680" y="1600200"/>
+            <a:ext cx="4754880" cy="457200"/>
+          </a:xfrm>
+          <a:prstGeom prst="rect">
+            <a:avLst/>
+          </a:prstGeom>
+          <a:noFill/>
+        </p:spPr>
+        <p:txBody>
+          <a:bodyPr wrap="square" anchor="t" lIns="0" rIns="0" tIns="0" bIns="0">
+            <a:spAutoFit/>
+          </a:bodyPr>
+          <a:lstStyle/>
+          <a:p>
+            <a:pPr algn="l">
+              <a:spcAft>
+                <a:spcPts val="600"/>
+              </a:spcAft>
+            </a:pPr>
+            <a:r>
+              <a:rPr sz="2200" b="1">
+                <a:solidFill>
+                  <a:srgbClr val="12262B"/>
+                </a:solidFill>
+              </a:rPr>
+              <a:t>Calibrated RUL bound</a:t>
+            </a:r>
+          </a:p>
+        </p:txBody>
+      </p:sp>
+      <p:sp>
+        <p:nvSpPr>
+          <p:cNvPr id="28" name="TextBox 27"/>
+          <p:cNvSpPr txBox="1"/>
+          <p:nvPr/>
+        </p:nvSpPr>
+        <p:spPr>
+          <a:xfrm>
+            <a:off x="868680" y="2194560"/>
+            <a:ext cx="4754880" cy="822960"/>
+          </a:xfrm>
+          <a:prstGeom prst="rect">
+            <a:avLst/>
+          </a:prstGeom>
+          <a:noFill/>
+        </p:spPr>
+        <p:txBody>
+          <a:bodyPr wrap="square" anchor="t" lIns="0" rIns="0" tIns="0" bIns="0">
+            <a:spAutoFit/>
+          </a:bodyPr>
+          <a:lstStyle/>
+          <a:p>
+            <a:pPr algn="l">
+              <a:spcAft>
+                <a:spcPts val="600"/>
+              </a:spcAft>
+            </a:pPr>
+            <a:r>
+              <a:rPr sz="4400" b="1">
+                <a:solidFill>
+                  <a:srgbClr val="D64545"/>
+                </a:solidFill>
+              </a:rPr>
+              <a:t>17-59 h</a:t>
+            </a:r>
+          </a:p>
+        </p:txBody>
+      </p:sp>
+      <p:sp>
+        <p:nvSpPr>
+          <p:cNvPr id="29" name="TextBox 28"/>
+          <p:cNvSpPr txBox="1"/>
+          <p:nvPr/>
+        </p:nvSpPr>
+        <p:spPr>
+          <a:xfrm>
+            <a:off x="868680" y="3017520"/>
+            <a:ext cx="4754880" cy="457200"/>
+          </a:xfrm>
+          <a:prstGeom prst="rect">
+            <a:avLst/>
+          </a:prstGeom>
+          <a:noFill/>
+        </p:spPr>
+        <p:txBody>
+          <a:bodyPr wrap="square" anchor="t" lIns="0" rIns="0" tIns="0" bIns="0">
+            <a:spAutoFit/>
+          </a:bodyPr>
+          <a:lstStyle/>
+          <a:p>
+            <a:pPr algn="l">
+              <a:spcAft>
+                <a:spcPts val="600"/>
+              </a:spcAft>
+            </a:pPr>
+            <a:r>
+              <a:rPr sz="1500" b="0">
+                <a:solidFill>
+                  <a:srgbClr val="5E6E70"/>
+                </a:solidFill>
+              </a:rPr>
+              <a:t>safety margin, as wide as the lead time</a:t>
+            </a:r>
+          </a:p>
+        </p:txBody>
+      </p:sp>
+      <p:sp>
+        <p:nvSpPr>
+          <p:cNvPr id="30" name="TextBox 29"/>
+          <p:cNvSpPr txBox="1"/>
+          <p:nvPr/>
+        </p:nvSpPr>
+        <p:spPr>
+          <a:xfrm>
+            <a:off x="868680" y="3749039"/>
+            <a:ext cx="4754880" cy="2194560"/>
+          </a:xfrm>
+          <a:prstGeom prst="rect">
+            <a:avLst/>
+          </a:prstGeom>
+          <a:noFill/>
+        </p:spPr>
+        <p:txBody>
+          <a:bodyPr wrap="square" anchor="t" lIns="0" rIns="0" tIns="0" bIns="0">
+            <a:spAutoFit/>
+          </a:bodyPr>
+          <a:lstStyle/>
+          <a:p>
+            <a:pPr algn="l">
+              <a:spcAft>
+                <a:spcPts val="1000"/>
+              </a:spcAft>
+            </a:pPr>
+            <a:r>
+              <a:rPr sz="1600" b="0">
+                <a:solidFill>
+                  <a:srgbClr val="12262B"/>
+                </a:solidFill>
+              </a:rPr>
+              <a:t>Never catches more than “act at the alarm”; at 4-8 h lead it catches fewer (3 vs 4)</a:t>
+            </a:r>
+          </a:p>
+          <a:p>
+            <a:pPr algn="l">
+              <a:spcAft>
+                <a:spcPts val="1000"/>
+              </a:spcAft>
+            </a:pPr>
+            <a:r>
+              <a:rPr sz="1600" b="0">
+                <a:solidFill>
+                  <a:srgbClr val="12262B"/>
+                </a:solidFill>
+              </a:rPr>
+              <a:t>After the alarm the bearings lasted 12, 53, 70, 97 h: too spread to learn from 3 examples</a:t>
+            </a:r>
+          </a:p>
+        </p:txBody>
+      </p:sp>
+      <p:sp>
+        <p:nvSpPr>
+          <p:cNvPr id="31" name="negative Foundation model (Chronos-2)"/>
+          <p:cNvSpPr/>
+          <p:nvPr/>
+        </p:nvSpPr>
+        <p:spPr>
+          <a:xfrm>
+            <a:off x="6217920" y="1371600"/>
+            <a:ext cx="5394960" cy="4023360"/>
+          </a:xfrm>
+          <a:prstGeom prst="roundRect">
+            <a:avLst>
+              <a:gd name="adj" fmla="val 8000"/>
+            </a:avLst>
+          </a:prstGeom>
+          <a:solidFill>
+            <a:schemeClr val="bg2"/>
+          </a:solidFill>
+          <a:ln>
+            <a:noFill/>
+          </a:ln>
+          <a:effectLst/>
+        </p:spPr>
+        <p:style>
+          <a:lnRef idx="1">
+            <a:schemeClr val="accent1"/>
+          </a:lnRef>
+          <a:fillRef idx="3">
+            <a:schemeClr val="accent1"/>
+          </a:fillRef>
+          <a:effectRef idx="2">
+            <a:schemeClr val="accent1"/>
+          </a:effectRef>
+          <a:fontRef idx="minor">
+            <a:schemeClr val="lt1"/>
+          </a:fontRef>
+        </p:style>
+        <p:txBody>
+          <a:bodyPr rtlCol="0" anchor="ctr"/>
+          <a:lstStyle/>
+          <a:p>
+            <a:pPr algn="ctr"/>
+          </a:p>
+        </p:txBody>
+      </p:sp>
+      <p:sp>
+        <p:nvSpPr>
           <p:cNvPr id="32" name="TextBox 31"/>
           <p:cNvSpPr txBox="1"/>
           <p:nvPr/>
@@ -4539,7 +5340,7 @@
 </p:sld>
 </file>
 
-<file path=ppt/slides/slide11.xml><?xml version="1.0" encoding="utf-8"?>
+<file path=ppt/slides/slide12.xml><?xml version="1.0" encoding="utf-8"?>
 <p:sld xmlns:a="http://schemas.openxmlformats.org/drawingml/2006/main" xmlns:p="http://schemas.openxmlformats.org/presentationml/2006/main" xmlns:r="http://schemas.openxmlformats.org/officeDocument/2006/relationships">
   <p:cSld>
     <p:spTree>
@@ -7673,6 +8474,561 @@
 </file>
 
 <file path=ppt/slides/slide6.xml><?xml version="1.0" encoding="utf-8"?>
+<p:sld xmlns:a="http://schemas.openxmlformats.org/drawingml/2006/main" xmlns:p="http://schemas.openxmlformats.org/presentationml/2006/main" xmlns:r="http://schemas.openxmlformats.org/officeDocument/2006/relationships">
+  <p:cSld>
+    <p:spTree>
+      <p:nvGrpSpPr>
+        <p:cNvPr id="1" name=""/>
+        <p:cNvGrpSpPr/>
+        <p:nvPr/>
+      </p:nvGrpSpPr>
+      <p:grpSpPr/>
+      <p:sp>
+        <p:nvSpPr>
+          <p:cNvPr id="2" name="Title 1"/>
+          <p:cNvSpPr>
+            <a:spLocks noGrp="1"/>
+          </p:cNvSpPr>
+          <p:nvPr>
+            <p:ph type="title" idx="100"/>
+          </p:nvPr>
+        </p:nvSpPr>
+        <p:spPr/>
+        <p:txBody>
+          <a:bodyPr/>
+          <a:lstStyle/>
+          <a:p>
+            <a:r>
+              <a:t>Replay: Part I spots the failure, Part II sends the crew</a:t>
+            </a:r>
+          </a:p>
+        </p:txBody>
+      </p:sp>
+      <p:sp>
+        <p:nvSpPr>
+          <p:cNvPr id="25" name="Slide Number Placeholder 0"/>
+          <p:cNvSpPr>
+            <a:spLocks noGrp="1"/>
+          </p:cNvSpPr>
+          <p:nvPr>
+            <p:ph type="sldNum" sz="quarter" idx="4294967295"/>
+          </p:nvPr>
+        </p:nvSpPr>
+        <p:spPr>
+          <a:xfrm>
+            <a:off x="11155680" y="6400800"/>
+            <a:ext cx="457200" cy="274320"/>
+          </a:xfrm>
+          <a:prstGeom prst="rect">
+            <a:avLst/>
+          </a:prstGeom>
+          <a:extLst>
+            <a:ext uri="{C572A759-6A51-4108-AA02-DFA0A04FC94B}">
+              <ma14:wrappingTextBoxFlag xmlns:ma14="http://schemas.microsoft.com/office/mac/drawingml/2011/main" val="0"/>
+            </a:ext>
+          </a:extLst>
+        </p:spPr>
+        <p:txBody>
+          <a:bodyPr/>
+          <a:lstStyle>
+            <a:lvl1pPr>
+              <a:defRPr sz="1000">
+                <a:solidFill>
+                  <a:srgbClr val="8A9A9B"/>
+                </a:solidFill>
+              </a:defRPr>
+            </a:lvl1pPr>
+          </a:lstStyle>
+          <a:p>
+            <a:pPr algn="r"/>
+            <a:fld id="{F7021451-1387-4CA6-816F-3879F97B5CBC}" type="slidenum">
+              <a:rPr b="0" lang="en-US"/>
+              <a:t>2</a:t>
+            </a:fld>
+            <a:endParaRPr lang="en-US"/>
+          </a:p>
+        </p:txBody>
+      </p:sp>
+      <p:pic>
+        <p:nvPicPr>
+          <p:cNvPr id="26" name="replay step 5" descr="Test 2, bearing 1 vibration over time. The alarm fires at hour 94; the crew needs 24 h and fits a new bearing at hour 118. After that a grey dashed line shows the old bearing in the real test, which nobody replaced, until it broke at hour 163.5.">
+            <a:hlinkClick r:id="rId4"/>
+          </p:cNvPr>
+          <p:cNvPicPr>
+            <a:picLocks noChangeAspect="1"/>
+          </p:cNvPicPr>
+          <p:nvPr/>
+        </p:nvPicPr>
+        <p:blipFill>
+          <a:blip r:embed="rId3"/>
+          <a:stretch>
+            <a:fillRect/>
+          </a:stretch>
+        </p:blipFill>
+        <p:spPr>
+          <a:xfrm>
+            <a:off x="457200" y="1371600"/>
+            <a:ext cx="8001000" cy="3437272"/>
+          </a:xfrm>
+          <a:prstGeom prst="rect">
+            <a:avLst/>
+          </a:prstGeom>
+        </p:spPr>
+      </p:pic>
+      <p:sp>
+        <p:nvSpPr>
+          <p:cNvPr id="27" name="replay caption"/>
+          <p:cNvSpPr txBox="1"/>
+          <p:nvPr/>
+        </p:nvSpPr>
+        <p:spPr>
+          <a:xfrm>
+            <a:off x="457200" y="4983480"/>
+            <a:ext cx="8001000" cy="640080"/>
+          </a:xfrm>
+          <a:prstGeom prst="rect">
+            <a:avLst/>
+          </a:prstGeom>
+          <a:noFill/>
+        </p:spPr>
+        <p:txBody>
+          <a:bodyPr wrap="square" anchor="t" lIns="0" rIns="0" tIns="0" bIns="0">
+            <a:spAutoFit/>
+          </a:bodyPr>
+          <a:lstStyle/>
+          <a:p>
+            <a:pPr algn="l">
+              <a:spcAft>
+                <a:spcPts val="600"/>
+              </a:spcAft>
+            </a:pPr>
+            <a:r>
+              <a:rPr sz="1400" b="0">
+                <a:solidFill>
+                  <a:srgbClr val="5E6E70"/>
+                </a:solidFill>
+              </a:rPr>
+              <a:t>Grey dashed line: the real test, where nobody replaced bearing 1, so it ran until it broke. With our rule it would have been replaced at hour 118.</a:t>
+            </a:r>
+          </a:p>
+        </p:txBody>
+      </p:sp>
+      <p:sp>
+        <p:nvSpPr>
+          <p:cNvPr id="28" name="badge 1"/>
+          <p:cNvSpPr/>
+          <p:nvPr/>
+        </p:nvSpPr>
+        <p:spPr>
+          <a:xfrm>
+            <a:off x="8686800" y="1463040"/>
+            <a:ext cx="384048" cy="384048"/>
+          </a:xfrm>
+          <a:prstGeom prst="ellipse">
+            <a:avLst/>
+          </a:prstGeom>
+          <a:solidFill>
+            <a:srgbClr val="1F8A8A"/>
+          </a:solidFill>
+          <a:ln>
+            <a:noFill/>
+          </a:ln>
+          <a:effectLst/>
+        </p:spPr>
+        <p:style>
+          <a:lnRef idx="1">
+            <a:schemeClr val="accent1"/>
+          </a:lnRef>
+          <a:fillRef idx="3">
+            <a:schemeClr val="accent1"/>
+          </a:fillRef>
+          <a:effectRef idx="2">
+            <a:schemeClr val="accent1"/>
+          </a:effectRef>
+          <a:fontRef idx="minor">
+            <a:schemeClr val="lt1"/>
+          </a:fontRef>
+        </p:style>
+        <p:txBody>
+          <a:bodyPr rtlCol="0" anchor="ctr" lIns="0" rIns="0" tIns="0" bIns="0"/>
+          <a:lstStyle/>
+          <a:p>
+            <a:pPr algn="ctr"/>
+            <a:r>
+              <a:rPr sz="1400" b="1">
+                <a:solidFill>
+                  <a:srgbClr val="FFFFFF"/>
+                </a:solidFill>
+              </a:rPr>
+              <a:t>1</a:t>
+            </a:r>
+          </a:p>
+        </p:txBody>
+      </p:sp>
+      <p:sp>
+        <p:nvSpPr>
+          <p:cNvPr id="29" name="replay step 1"/>
+          <p:cNvSpPr txBox="1"/>
+          <p:nvPr/>
+        </p:nvSpPr>
+        <p:spPr>
+          <a:xfrm>
+            <a:off x="9189720" y="1435608"/>
+            <a:ext cx="2560320" cy="868680"/>
+          </a:xfrm>
+          <a:prstGeom prst="rect">
+            <a:avLst/>
+          </a:prstGeom>
+          <a:noFill/>
+        </p:spPr>
+        <p:txBody>
+          <a:bodyPr wrap="square" anchor="t" lIns="0" rIns="0" tIns="0" bIns="0">
+            <a:spAutoFit/>
+          </a:bodyPr>
+          <a:lstStyle/>
+          <a:p>
+            <a:pPr algn="l">
+              <a:spcAft>
+                <a:spcPts val="600"/>
+              </a:spcAft>
+            </a:pPr>
+            <a:r>
+              <a:rPr sz="1400" b="0">
+                <a:solidFill>
+                  <a:srgbClr val="12262B"/>
+                </a:solidFill>
+              </a:rPr>
+              <a:t>Bearing 1 starts to vibrate more, around hour 90</a:t>
+            </a:r>
+          </a:p>
+        </p:txBody>
+      </p:sp>
+      <p:sp>
+        <p:nvSpPr>
+          <p:cNvPr id="30" name="badge 2"/>
+          <p:cNvSpPr/>
+          <p:nvPr/>
+        </p:nvSpPr>
+        <p:spPr>
+          <a:xfrm>
+            <a:off x="8686800" y="2377440"/>
+            <a:ext cx="384048" cy="384048"/>
+          </a:xfrm>
+          <a:prstGeom prst="ellipse">
+            <a:avLst/>
+          </a:prstGeom>
+          <a:solidFill>
+            <a:srgbClr val="1F8A8A"/>
+          </a:solidFill>
+          <a:ln>
+            <a:noFill/>
+          </a:ln>
+          <a:effectLst/>
+        </p:spPr>
+        <p:style>
+          <a:lnRef idx="1">
+            <a:schemeClr val="accent1"/>
+          </a:lnRef>
+          <a:fillRef idx="3">
+            <a:schemeClr val="accent1"/>
+          </a:fillRef>
+          <a:effectRef idx="2">
+            <a:schemeClr val="accent1"/>
+          </a:effectRef>
+          <a:fontRef idx="minor">
+            <a:schemeClr val="lt1"/>
+          </a:fontRef>
+        </p:style>
+        <p:txBody>
+          <a:bodyPr rtlCol="0" anchor="ctr" lIns="0" rIns="0" tIns="0" bIns="0"/>
+          <a:lstStyle/>
+          <a:p>
+            <a:pPr algn="ctr"/>
+            <a:r>
+              <a:rPr sz="1400" b="1">
+                <a:solidFill>
+                  <a:srgbClr val="FFFFFF"/>
+                </a:solidFill>
+              </a:rPr>
+              <a:t>2</a:t>
+            </a:r>
+          </a:p>
+        </p:txBody>
+      </p:sp>
+      <p:sp>
+        <p:nvSpPr>
+          <p:cNvPr id="31" name="replay step 2"/>
+          <p:cNvSpPr txBox="1"/>
+          <p:nvPr/>
+        </p:nvSpPr>
+        <p:spPr>
+          <a:xfrm>
+            <a:off x="9189720" y="2350008"/>
+            <a:ext cx="2560320" cy="868680"/>
+          </a:xfrm>
+          <a:prstGeom prst="rect">
+            <a:avLst/>
+          </a:prstGeom>
+          <a:noFill/>
+        </p:spPr>
+        <p:txBody>
+          <a:bodyPr wrap="square" anchor="t" lIns="0" rIns="0" tIns="0" bIns="0">
+            <a:spAutoFit/>
+          </a:bodyPr>
+          <a:lstStyle/>
+          <a:p>
+            <a:pPr algn="l">
+              <a:spcAft>
+                <a:spcPts val="600"/>
+              </a:spcAft>
+            </a:pPr>
+            <a:r>
+              <a:rPr sz="1400" b="0">
+                <a:solidFill>
+                  <a:srgbClr val="12262B"/>
+                </a:solidFill>
+              </a:rPr>
+              <a:t>Part I: alarm at hour 94 (the AI agrees at 110); Stage B says outer race</a:t>
+            </a:r>
+          </a:p>
+        </p:txBody>
+      </p:sp>
+      <p:sp>
+        <p:nvSpPr>
+          <p:cNvPr id="32" name="badge 3"/>
+          <p:cNvSpPr/>
+          <p:nvPr/>
+        </p:nvSpPr>
+        <p:spPr>
+          <a:xfrm>
+            <a:off x="8686800" y="3291840"/>
+            <a:ext cx="384048" cy="384048"/>
+          </a:xfrm>
+          <a:prstGeom prst="ellipse">
+            <a:avLst/>
+          </a:prstGeom>
+          <a:solidFill>
+            <a:srgbClr val="1F8A8A"/>
+          </a:solidFill>
+          <a:ln>
+            <a:noFill/>
+          </a:ln>
+          <a:effectLst/>
+        </p:spPr>
+        <p:style>
+          <a:lnRef idx="1">
+            <a:schemeClr val="accent1"/>
+          </a:lnRef>
+          <a:fillRef idx="3">
+            <a:schemeClr val="accent1"/>
+          </a:fillRef>
+          <a:effectRef idx="2">
+            <a:schemeClr val="accent1"/>
+          </a:effectRef>
+          <a:fontRef idx="minor">
+            <a:schemeClr val="lt1"/>
+          </a:fontRef>
+        </p:style>
+        <p:txBody>
+          <a:bodyPr rtlCol="0" anchor="ctr" lIns="0" rIns="0" tIns="0" bIns="0"/>
+          <a:lstStyle/>
+          <a:p>
+            <a:pPr algn="ctr"/>
+            <a:r>
+              <a:rPr sz="1400" b="1">
+                <a:solidFill>
+                  <a:srgbClr val="FFFFFF"/>
+                </a:solidFill>
+              </a:rPr>
+              <a:t>3</a:t>
+            </a:r>
+          </a:p>
+        </p:txBody>
+      </p:sp>
+      <p:sp>
+        <p:nvSpPr>
+          <p:cNvPr id="33" name="replay step 3"/>
+          <p:cNvSpPr txBox="1"/>
+          <p:nvPr/>
+        </p:nvSpPr>
+        <p:spPr>
+          <a:xfrm>
+            <a:off x="9189720" y="3264408"/>
+            <a:ext cx="2560320" cy="868680"/>
+          </a:xfrm>
+          <a:prstGeom prst="rect">
+            <a:avLst/>
+          </a:prstGeom>
+          <a:noFill/>
+        </p:spPr>
+        <p:txBody>
+          <a:bodyPr wrap="square" anchor="t" lIns="0" rIns="0" tIns="0" bIns="0">
+            <a:spAutoFit/>
+          </a:bodyPr>
+          <a:lstStyle/>
+          <a:p>
+            <a:pPr algn="l">
+              <a:spcAft>
+                <a:spcPts val="600"/>
+              </a:spcAft>
+            </a:pPr>
+            <a:r>
+              <a:rPr sz="1400" b="0">
+                <a:solidFill>
+                  <a:srgbClr val="12262B"/>
+                </a:solidFill>
+              </a:rPr>
+              <a:t>Part II: the crew needs 24 h, new bearing at hour 118, 45.5 h before the breakdown</a:t>
+            </a:r>
+          </a:p>
+        </p:txBody>
+      </p:sp>
+      <p:sp>
+        <p:nvSpPr>
+          <p:cNvPr id="34" name="badge 4"/>
+          <p:cNvSpPr/>
+          <p:nvPr/>
+        </p:nvSpPr>
+        <p:spPr>
+          <a:xfrm>
+            <a:off x="8686800" y="4206240"/>
+            <a:ext cx="384048" cy="384048"/>
+          </a:xfrm>
+          <a:prstGeom prst="ellipse">
+            <a:avLst/>
+          </a:prstGeom>
+          <a:solidFill>
+            <a:srgbClr val="F26B4F"/>
+          </a:solidFill>
+          <a:ln>
+            <a:noFill/>
+          </a:ln>
+          <a:effectLst/>
+        </p:spPr>
+        <p:style>
+          <a:lnRef idx="1">
+            <a:schemeClr val="accent1"/>
+          </a:lnRef>
+          <a:fillRef idx="3">
+            <a:schemeClr val="accent1"/>
+          </a:fillRef>
+          <a:effectRef idx="2">
+            <a:schemeClr val="accent1"/>
+          </a:effectRef>
+          <a:fontRef idx="minor">
+            <a:schemeClr val="lt1"/>
+          </a:fontRef>
+        </p:style>
+        <p:txBody>
+          <a:bodyPr rtlCol="0" anchor="ctr" lIns="0" rIns="0" tIns="0" bIns="0"/>
+          <a:lstStyle/>
+          <a:p>
+            <a:pPr algn="ctr"/>
+            <a:r>
+              <a:rPr sz="1400" b="1">
+                <a:solidFill>
+                  <a:srgbClr val="FFFFFF"/>
+                </a:solidFill>
+              </a:rPr>
+              <a:t>4</a:t>
+            </a:r>
+          </a:p>
+        </p:txBody>
+      </p:sp>
+      <p:sp>
+        <p:nvSpPr>
+          <p:cNvPr id="35" name="replay step 4"/>
+          <p:cNvSpPr txBox="1"/>
+          <p:nvPr/>
+        </p:nvSpPr>
+        <p:spPr>
+          <a:xfrm>
+            <a:off x="9189720" y="4178807"/>
+            <a:ext cx="2560320" cy="868680"/>
+          </a:xfrm>
+          <a:prstGeom prst="rect">
+            <a:avLst/>
+          </a:prstGeom>
+          <a:noFill/>
+        </p:spPr>
+        <p:txBody>
+          <a:bodyPr wrap="square" anchor="t" lIns="0" rIns="0" tIns="0" bIns="0">
+            <a:spAutoFit/>
+          </a:bodyPr>
+          <a:lstStyle/>
+          <a:p>
+            <a:pPr algn="l">
+              <a:spcAft>
+                <a:spcPts val="600"/>
+              </a:spcAft>
+            </a:pPr>
+            <a:r>
+              <a:rPr sz="1400" b="0">
+                <a:solidFill>
+                  <a:srgbClr val="12262B"/>
+                </a:solidFill>
+              </a:rPr>
+              <a:t>Cost 1 for a planned replacement instead of 10 for a breakdown</a:t>
+            </a:r>
+          </a:p>
+        </p:txBody>
+      </p:sp>
+      <p:sp>
+        <p:nvSpPr>
+          <p:cNvPr id="36" name="replay link"/>
+          <p:cNvSpPr txBox="1"/>
+          <p:nvPr/>
+        </p:nvSpPr>
+        <p:spPr>
+          <a:xfrm>
+            <a:off x="8686800" y="5257800"/>
+            <a:ext cx="3108960" cy="365760"/>
+          </a:xfrm>
+          <a:prstGeom prst="rect">
+            <a:avLst/>
+          </a:prstGeom>
+          <a:noFill/>
+        </p:spPr>
+        <p:txBody>
+          <a:bodyPr wrap="square" anchor="t" lIns="0" rIns="0" tIns="0" bIns="0">
+            <a:spAutoFit/>
+          </a:bodyPr>
+          <a:lstStyle/>
+          <a:p>
+            <a:pPr algn="l">
+              <a:spcAft>
+                <a:spcPts val="600"/>
+              </a:spcAft>
+            </a:pPr>
+            <a:r>
+              <a:rPr sz="1400" b="1">
+                <a:solidFill>
+                  <a:srgbClr val="F26B4F"/>
+                </a:solidFill>
+              </a:rPr>
+              <a:t>▶ Live replay: </a:t>
+            </a:r>
+            <a:r>
+              <a:rPr sz="1400" b="1">
+                <a:solidFill>
+                  <a:srgbClr val="0F4C5C"/>
+                </a:solidFill>
+                <a:hlinkClick r:id="rId4"/>
+              </a:rPr>
+              <a:t>bearing_replay.html</a:t>
+            </a:r>
+          </a:p>
+        </p:txBody>
+      </p:sp>
+    </p:spTree>
+  </p:cSld>
+  <p:clrMapOvr>
+    <a:masterClrMapping/>
+  </p:clrMapOvr>
+</p:sld>
+</file>
+
+<file path=ppt/slides/slide7.xml><?xml version="1.0" encoding="utf-8"?>
 <p:sld xmlns:a="http://schemas.openxmlformats.org/drawingml/2006/main" xmlns:p="http://schemas.openxmlformats.org/presentationml/2006/main" xmlns:r="http://schemas.openxmlformats.org/officeDocument/2006/relationships">
   <p:cSld>
     <p:spTree>
@@ -9535,7 +10891,7 @@
 </p:sld>
 </file>
 
-<file path=ppt/slides/slide7.xml><?xml version="1.0" encoding="utf-8"?>
+<file path=ppt/slides/slide8.xml><?xml version="1.0" encoding="utf-8"?>
 <p:sld xmlns:a="http://schemas.openxmlformats.org/drawingml/2006/main" xmlns:p="http://schemas.openxmlformats.org/presentationml/2006/main" xmlns:r="http://schemas.openxmlformats.org/officeDocument/2006/relationships">
   <p:cSld>
     <p:spTree>
@@ -9830,313 +11186,6 @@
                 </a:solidFill>
               </a:rPr>
               <a:t>Grey flattens only through hindsight tuning</a:t>
-            </a:r>
-          </a:p>
-        </p:txBody>
-      </p:sp>
-    </p:spTree>
-  </p:cSld>
-  <p:clrMapOvr>
-    <a:masterClrMapping/>
-  </p:clrMapOvr>
-</p:sld>
-</file>
-
-<file path=ppt/slides/slide8.xml><?xml version="1.0" encoding="utf-8"?>
-<p:sld xmlns:a="http://schemas.openxmlformats.org/drawingml/2006/main" xmlns:p="http://schemas.openxmlformats.org/presentationml/2006/main" xmlns:r="http://schemas.openxmlformats.org/officeDocument/2006/relationships">
-  <p:cSld>
-    <p:spTree>
-      <p:nvGrpSpPr>
-        <p:cNvPr id="1" name=""/>
-        <p:cNvGrpSpPr/>
-        <p:nvPr/>
-      </p:nvGrpSpPr>
-      <p:grpSpPr/>
-      <p:sp>
-        <p:nvSpPr>
-          <p:cNvPr id="2" name="Title 1"/>
-          <p:cNvSpPr>
-            <a:spLocks noGrp="1"/>
-          </p:cNvSpPr>
-          <p:nvPr>
-            <p:ph type="title" idx="100"/>
-          </p:nvPr>
-        </p:nvSpPr>
-        <p:spPr/>
-        <p:txBody>
-          <a:bodyPr/>
-          <a:lstStyle/>
-          <a:p>
-            <a:r>
-              <a:t>The crew must replace the bearing within about 2 days</a:t>
-            </a:r>
-          </a:p>
-        </p:txBody>
-      </p:sp>
-      <p:sp>
-        <p:nvSpPr>
-          <p:cNvPr id="25" name="Slide Number Placeholder 0"/>
-          <p:cNvSpPr>
-            <a:spLocks noGrp="1"/>
-          </p:cNvSpPr>
-          <p:nvPr>
-            <p:ph type="sldNum" sz="quarter" idx="4294967295"/>
-          </p:nvPr>
-        </p:nvSpPr>
-        <p:spPr>
-          <a:xfrm>
-            <a:off x="11155680" y="6400800"/>
-            <a:ext cx="457200" cy="274320"/>
-          </a:xfrm>
-          <a:prstGeom prst="rect">
-            <a:avLst/>
-          </a:prstGeom>
-          <a:extLst>
-            <a:ext uri="{C572A759-6A51-4108-AA02-DFA0A04FC94B}">
-              <ma14:wrappingTextBoxFlag xmlns:ma14="http://schemas.microsoft.com/office/mac/drawingml/2011/main" val="0"/>
-            </a:ext>
-          </a:extLst>
-        </p:spPr>
-        <p:txBody>
-          <a:bodyPr/>
-          <a:lstStyle>
-            <a:lvl1pPr>
-              <a:defRPr sz="1000">
-                <a:solidFill>
-                  <a:srgbClr val="8A9A9B"/>
-                </a:solidFill>
-              </a:defRPr>
-            </a:lvl1pPr>
-          </a:lstStyle>
-          <a:p>
-            <a:pPr algn="r"/>
-            <a:fld id="{F7021451-1387-4CA6-816F-3879F97B5CBC}" type="slidenum">
-              <a:rPr b="0" lang="en-US"/>
-              <a:t>2</a:t>
-            </a:fld>
-            <a:endParaRPr lang="en-US"/>
-          </a:p>
-        </p:txBody>
-      </p:sp>
-      <p:graphicFrame>
-        <p:nvGraphicFramePr>
-          <p:cNvPr id="26" name="Chart 25"/>
-          <p:cNvGraphicFramePr>
-            <a:graphicFrameLocks noGrp="1"/>
-          </p:cNvGraphicFramePr>
-          <p:nvPr/>
-        </p:nvGraphicFramePr>
-        <p:xfrm>
-          <a:off x="548640" y="1234440"/>
-          <a:ext cx="8138160" cy="4983480"/>
-        </p:xfrm>
-        <a:graphic>
-          <a:graphicData uri="http://schemas.openxmlformats.org/drawingml/2006/chart">
-            <c:chart xmlns:c="http://schemas.openxmlformats.org/drawingml/2006/chart" r:id="rId3"/>
-          </a:graphicData>
-        </a:graphic>
-      </p:graphicFrame>
-      <p:sp>
-        <p:nvSpPr>
-          <p:cNvPr id="27" name="stat ≤ 48 h"/>
-          <p:cNvSpPr txBox="1"/>
-          <p:nvPr/>
-        </p:nvSpPr>
-        <p:spPr>
-          <a:xfrm>
-            <a:off x="9052560" y="1280160"/>
-            <a:ext cx="2560320" cy="777240"/>
-          </a:xfrm>
-          <a:prstGeom prst="rect">
-            <a:avLst/>
-          </a:prstGeom>
-          <a:noFill/>
-        </p:spPr>
-        <p:txBody>
-          <a:bodyPr wrap="square" anchor="t" lIns="0" rIns="0" tIns="0" bIns="0">
-            <a:spAutoFit/>
-          </a:bodyPr>
-          <a:lstStyle/>
-          <a:p>
-            <a:pPr algn="l">
-              <a:spcAft>
-                <a:spcPts val="600"/>
-              </a:spcAft>
-            </a:pPr>
-            <a:r>
-              <a:rPr sz="4400" b="1">
-                <a:solidFill>
-                  <a:srgbClr val="F26B4F"/>
-                </a:solidFill>
-              </a:rPr>
-              <a:t>≤ 48 h</a:t>
-            </a:r>
-          </a:p>
-        </p:txBody>
-      </p:sp>
-      <p:sp>
-        <p:nvSpPr>
-          <p:cNvPr id="28" name="TextBox 27"/>
-          <p:cNvSpPr txBox="1"/>
-          <p:nvPr/>
-        </p:nvSpPr>
-        <p:spPr>
-          <a:xfrm>
-            <a:off x="9052560" y="2057400"/>
-            <a:ext cx="2560320" cy="640080"/>
-          </a:xfrm>
-          <a:prstGeom prst="rect">
-            <a:avLst/>
-          </a:prstGeom>
-          <a:noFill/>
-        </p:spPr>
-        <p:txBody>
-          <a:bodyPr wrap="square" anchor="t" lIns="0" rIns="0" tIns="0" bIns="0">
-            <a:spAutoFit/>
-          </a:bodyPr>
-          <a:lstStyle/>
-          <a:p>
-            <a:pPr algn="l">
-              <a:spcAft>
-                <a:spcPts val="600"/>
-              </a:spcAft>
-            </a:pPr>
-            <a:r>
-              <a:rPr sz="1500" b="0">
-                <a:solidFill>
-                  <a:srgbClr val="5E6E70"/>
-                </a:solidFill>
-              </a:rPr>
-              <a:t>lead time where acting on either alarm catches all 4</a:t>
-            </a:r>
-          </a:p>
-        </p:txBody>
-      </p:sp>
-      <p:sp>
-        <p:nvSpPr>
-          <p:cNvPr id="29" name="lead note"/>
-          <p:cNvSpPr/>
-          <p:nvPr/>
-        </p:nvSpPr>
-        <p:spPr>
-          <a:xfrm>
-            <a:off x="9052560" y="3017520"/>
-            <a:ext cx="2560320" cy="2651760"/>
-          </a:xfrm>
-          <a:prstGeom prst="roundRect">
-            <a:avLst>
-              <a:gd name="adj" fmla="val 8000"/>
-            </a:avLst>
-          </a:prstGeom>
-          <a:solidFill>
-            <a:schemeClr val="bg2"/>
-          </a:solidFill>
-          <a:ln>
-            <a:noFill/>
-          </a:ln>
-          <a:effectLst/>
-        </p:spPr>
-        <p:style>
-          <a:lnRef idx="1">
-            <a:schemeClr val="accent1"/>
-          </a:lnRef>
-          <a:fillRef idx="3">
-            <a:schemeClr val="accent1"/>
-          </a:fillRef>
-          <a:effectRef idx="2">
-            <a:schemeClr val="accent1"/>
-          </a:effectRef>
-          <a:fontRef idx="minor">
-            <a:schemeClr val="lt1"/>
-          </a:fontRef>
-        </p:style>
-        <p:txBody>
-          <a:bodyPr rtlCol="0" anchor="ctr"/>
-          <a:lstStyle/>
-          <a:p>
-            <a:pPr algn="ctr"/>
-          </a:p>
-        </p:txBody>
-      </p:sp>
-      <p:sp>
-        <p:nvSpPr>
-          <p:cNvPr id="30" name="TextBox 29"/>
-          <p:cNvSpPr txBox="1"/>
-          <p:nvPr/>
-        </p:nvSpPr>
-        <p:spPr>
-          <a:xfrm>
-            <a:off x="9235440" y="3154680"/>
-            <a:ext cx="2194560" cy="2468880"/>
-          </a:xfrm>
-          <a:prstGeom prst="rect">
-            <a:avLst/>
-          </a:prstGeom>
-          <a:noFill/>
-        </p:spPr>
-        <p:txBody>
-          <a:bodyPr wrap="square" anchor="t" lIns="0" rIns="0" tIns="0" bIns="0">
-            <a:spAutoFit/>
-          </a:bodyPr>
-          <a:lstStyle/>
-          <a:p>
-            <a:pPr algn="l">
-              <a:spcAft>
-                <a:spcPts val="600"/>
-              </a:spcAft>
-            </a:pPr>
-            <a:r>
-              <a:rPr sz="1800" b="1">
-                <a:solidFill>
-                  <a:srgbClr val="12262B"/>
-                </a:solidFill>
-              </a:rPr>
-              <a:t>At default thresholds</a:t>
-            </a:r>
-          </a:p>
-          <a:p>
-            <a:pPr algn="l">
-              <a:spcAft>
-                <a:spcPts val="600"/>
-              </a:spcAft>
-            </a:pPr>
-            <a:r>
-              <a:rPr sz="1500" b="0">
-                <a:solidFill>
-                  <a:srgbClr val="12262B"/>
-                </a:solidFill>
-              </a:rPr>
-              <a:t>≤ 8 h: physics alone is enough</a:t>
-            </a:r>
-          </a:p>
-          <a:p>
-            <a:pPr algn="l">
-              <a:spcAft>
-                <a:spcPts val="600"/>
-              </a:spcAft>
-            </a:pPr>
-            <a:r>
-              <a:rPr sz="1500" b="0">
-                <a:solidFill>
-                  <a:srgbClr val="12262B"/>
-                </a:solidFill>
-              </a:rPr>
-              <a:t>12-48 h: only physics OR AI catches all 4</a:t>
-            </a:r>
-          </a:p>
-          <a:p>
-            <a:pPr algn="l">
-              <a:spcAft>
-                <a:spcPts val="600"/>
-              </a:spcAft>
-            </a:pPr>
-            <a:r>
-              <a:rPr sz="1500" b="0">
-                <a:solidFill>
-                  <a:srgbClr val="12262B"/>
-                </a:solidFill>
-              </a:rPr>
-              <a:t>72 h: each rule catches only 1 of 4</a:t>
             </a:r>
           </a:p>
         </p:txBody>
@@ -10175,7 +11224,7 @@
           <a:lstStyle/>
           <a:p>
             <a:r>
-              <a:t>Robustness: either alarm catches all 4 in every setting tried</a:t>
+              <a:t>The crew must replace the bearing within about 2 days</a:t>
             </a:r>
           </a:p>
         </p:txBody>
@@ -10227,463 +11276,25 @@
       </p:sp>
       <p:graphicFrame>
         <p:nvGraphicFramePr>
-          <p:cNvPr id="26" name="Table 25"/>
+          <p:cNvPr id="26" name="Chart 25"/>
           <p:cNvGraphicFramePr>
             <a:graphicFrameLocks noGrp="1"/>
           </p:cNvGraphicFramePr>
           <p:nvPr/>
         </p:nvGraphicFramePr>
         <p:xfrm>
-          <a:off x="548640" y="1371600"/>
-          <a:ext cx="8138160" cy="3886200"/>
+          <a:off x="548640" y="1234440"/>
+          <a:ext cx="8138160" cy="4983480"/>
         </p:xfrm>
         <a:graphic>
-          <a:graphicData uri="http://schemas.openxmlformats.org/drawingml/2006/table">
-            <a:tbl>
-              <a:tblPr firstRow="1">
-                <a:tableStyleId>{5C22544A-7EE6-4342-B048-85BDC9FD1C3A}</a:tableStyleId>
-              </a:tblPr>
-              <a:tblGrid>
-                <a:gridCol w="2651760"/>
-                <a:gridCol w="5486400"/>
-              </a:tblGrid>
-              <a:tr h="777240">
-                <a:tc>
-                  <a:txBody>
-                    <a:bodyPr wrap="square"/>
-                    <a:lstStyle/>
-                    <a:p>
-                      <a:pPr algn="l"/>
-                      <a:r>
-                        <a:rPr sz="1400" b="1">
-                          <a:solidFill>
-                            <a:srgbClr val="FFFFFF"/>
-                          </a:solidFill>
-                        </a:rPr>
-                        <a:t>Check</a:t>
-                      </a:r>
-                    </a:p>
-                  </a:txBody>
-                  <a:tcPr anchor="ctr" marL="73152" marR="73152">
-                    <a:lnL w="9525">
-                      <a:solidFill>
-                        <a:srgbClr val="D3E2E0"/>
-                      </a:solidFill>
-                    </a:lnL>
-                    <a:lnR w="9525">
-                      <a:solidFill>
-                        <a:srgbClr val="D3E2E0"/>
-                      </a:solidFill>
-                    </a:lnR>
-                    <a:lnT w="9525">
-                      <a:solidFill>
-                        <a:srgbClr val="D3E2E0"/>
-                      </a:solidFill>
-                    </a:lnT>
-                    <a:lnB w="9525">
-                      <a:solidFill>
-                        <a:srgbClr val="D3E2E0"/>
-                      </a:solidFill>
-                    </a:lnB>
-                    <a:solidFill>
-                      <a:srgbClr val="0F4C5C"/>
-                    </a:solidFill>
-                  </a:tcPr>
-                </a:tc>
-                <a:tc>
-                  <a:txBody>
-                    <a:bodyPr wrap="square"/>
-                    <a:lstStyle/>
-                    <a:p>
-                      <a:pPr algn="l"/>
-                      <a:r>
-                        <a:rPr sz="1400" b="1">
-                          <a:solidFill>
-                            <a:srgbClr val="FFFFFF"/>
-                          </a:solidFill>
-                        </a:rPr>
-                        <a:t>Result</a:t>
-                      </a:r>
-                    </a:p>
-                  </a:txBody>
-                  <a:tcPr anchor="ctr" marL="73152" marR="73152">
-                    <a:lnL w="9525">
-                      <a:solidFill>
-                        <a:srgbClr val="D3E2E0"/>
-                      </a:solidFill>
-                    </a:lnL>
-                    <a:lnR w="9525">
-                      <a:solidFill>
-                        <a:srgbClr val="D3E2E0"/>
-                      </a:solidFill>
-                    </a:lnR>
-                    <a:lnT w="9525">
-                      <a:solidFill>
-                        <a:srgbClr val="D3E2E0"/>
-                      </a:solidFill>
-                    </a:lnT>
-                    <a:lnB w="9525">
-                      <a:solidFill>
-                        <a:srgbClr val="D3E2E0"/>
-                      </a:solidFill>
-                    </a:lnB>
-                    <a:solidFill>
-                      <a:srgbClr val="0F4C5C"/>
-                    </a:solidFill>
-                  </a:tcPr>
-                </a:tc>
-              </a:tr>
-              <a:tr h="777240">
-                <a:tc>
-                  <a:txBody>
-                    <a:bodyPr wrap="square"/>
-                    <a:lstStyle/>
-                    <a:p>
-                      <a:pPr algn="l"/>
-                      <a:r>
-                        <a:rPr sz="1500" b="0">
-                          <a:solidFill>
-                            <a:srgbClr val="12262B"/>
-                          </a:solidFill>
-                        </a:rPr>
-                        <a:t>27 threshold settings (lead 24 h, breakdown 10×)</a:t>
-                      </a:r>
-                    </a:p>
-                  </a:txBody>
-                  <a:tcPr anchor="ctr" marL="73152" marR="73152">
-                    <a:lnL w="9525">
-                      <a:solidFill>
-                        <a:srgbClr val="D3E2E0"/>
-                      </a:solidFill>
-                    </a:lnL>
-                    <a:lnR w="9525">
-                      <a:solidFill>
-                        <a:srgbClr val="D3E2E0"/>
-                      </a:solidFill>
-                    </a:lnR>
-                    <a:lnT w="9525">
-                      <a:solidFill>
-                        <a:srgbClr val="D3E2E0"/>
-                      </a:solidFill>
-                    </a:lnT>
-                    <a:lnB w="9525">
-                      <a:solidFill>
-                        <a:srgbClr val="D3E2E0"/>
-                      </a:solidFill>
-                    </a:lnB>
-                    <a:solidFill>
-                      <a:srgbClr val="FFFFFF"/>
-                    </a:solidFill>
-                  </a:tcPr>
-                </a:tc>
-                <a:tc>
-                  <a:txBody>
-                    <a:bodyPr wrap="square"/>
-                    <a:lstStyle/>
-                    <a:p>
-                      <a:pPr algn="l"/>
-                      <a:r>
-                        <a:rPr sz="1500" b="0">
-                          <a:solidFill>
-                            <a:srgbClr val="12262B"/>
-                          </a:solidFill>
-                        </a:rPr>
-                        <a:t>Physics OR AI: 4/4 in 27/27, cost 0.81-1.08. Physics alone: 4/4 in 9/27. AI floor changed nothing: 9 distinct outcomes</a:t>
-                      </a:r>
-                    </a:p>
-                  </a:txBody>
-                  <a:tcPr anchor="ctr" marL="73152" marR="73152">
-                    <a:lnL w="9525">
-                      <a:solidFill>
-                        <a:srgbClr val="D3E2E0"/>
-                      </a:solidFill>
-                    </a:lnL>
-                    <a:lnR w="9525">
-                      <a:solidFill>
-                        <a:srgbClr val="D3E2E0"/>
-                      </a:solidFill>
-                    </a:lnR>
-                    <a:lnT w="9525">
-                      <a:solidFill>
-                        <a:srgbClr val="D3E2E0"/>
-                      </a:solidFill>
-                    </a:lnT>
-                    <a:lnB w="9525">
-                      <a:solidFill>
-                        <a:srgbClr val="D3E2E0"/>
-                      </a:solidFill>
-                    </a:lnB>
-                    <a:solidFill>
-                      <a:srgbClr val="FFFFFF"/>
-                    </a:solidFill>
-                  </a:tcPr>
-                </a:tc>
-              </a:tr>
-              <a:tr h="777240">
-                <a:tc>
-                  <a:txBody>
-                    <a:bodyPr wrap="square"/>
-                    <a:lstStyle/>
-                    <a:p>
-                      <a:pPr algn="l"/>
-                      <a:r>
-                        <a:rPr sz="1500" b="0">
-                          <a:solidFill>
-                            <a:srgbClr val="12262B"/>
-                          </a:solidFill>
-                        </a:rPr>
-                        <a:t>Drop one test, re-score the other two (sensitivity check)</a:t>
-                      </a:r>
-                    </a:p>
-                  </a:txBody>
-                  <a:tcPr anchor="ctr" marL="73152" marR="73152">
-                    <a:lnL w="9525">
-                      <a:solidFill>
-                        <a:srgbClr val="D3E2E0"/>
-                      </a:solidFill>
-                    </a:lnL>
-                    <a:lnR w="9525">
-                      <a:solidFill>
-                        <a:srgbClr val="D3E2E0"/>
-                      </a:solidFill>
-                    </a:lnR>
-                    <a:lnT w="9525">
-                      <a:solidFill>
-                        <a:srgbClr val="D3E2E0"/>
-                      </a:solidFill>
-                    </a:lnT>
-                    <a:lnB w="9525">
-                      <a:solidFill>
-                        <a:srgbClr val="D3E2E0"/>
-                      </a:solidFill>
-                    </a:lnB>
-                    <a:solidFill>
-                      <a:srgbClr val="FFFFFF"/>
-                    </a:solidFill>
-                  </a:tcPr>
-                </a:tc>
-                <a:tc>
-                  <a:txBody>
-                    <a:bodyPr wrap="square"/>
-                    <a:lstStyle/>
-                    <a:p>
-                      <a:pPr algn="l"/>
-                      <a:r>
-                        <a:rPr sz="1500" b="0">
-                          <a:solidFill>
-                            <a:srgbClr val="12262B"/>
-                          </a:solidFill>
-                        </a:rPr>
-                        <a:t>Physics OR AI beats reactive (3.9-7.6) and preventive (1.2-3.5) every time; single alarms do not (set 2 dropped: preventive 1.21 vs physics 1.91, AI 1.61)</a:t>
-                      </a:r>
-                    </a:p>
-                  </a:txBody>
-                  <a:tcPr anchor="ctr" marL="73152" marR="73152">
-                    <a:lnL w="9525">
-                      <a:solidFill>
-                        <a:srgbClr val="D3E2E0"/>
-                      </a:solidFill>
-                    </a:lnL>
-                    <a:lnR w="9525">
-                      <a:solidFill>
-                        <a:srgbClr val="D3E2E0"/>
-                      </a:solidFill>
-                    </a:lnR>
-                    <a:lnT w="9525">
-                      <a:solidFill>
-                        <a:srgbClr val="D3E2E0"/>
-                      </a:solidFill>
-                    </a:lnT>
-                    <a:lnB w="9525">
-                      <a:solidFill>
-                        <a:srgbClr val="D3E2E0"/>
-                      </a:solidFill>
-                    </a:lnB>
-                    <a:solidFill>
-                      <a:srgbClr val="FFFFFF"/>
-                    </a:solidFill>
-                  </a:tcPr>
-                </a:tc>
-              </a:tr>
-              <a:tr h="777240">
-                <a:tc>
-                  <a:txBody>
-                    <a:bodyPr wrap="square"/>
-                    <a:lstStyle/>
-                    <a:p>
-                      <a:pPr algn="l"/>
-                      <a:r>
-                        <a:rPr sz="1500" b="0">
-                          <a:solidFill>
-                            <a:srgbClr val="12262B"/>
-                          </a:solidFill>
-                        </a:rPr>
-                        <a:t>False alarm 5× a planned job</a:t>
-                      </a:r>
-                    </a:p>
-                  </a:txBody>
-                  <a:tcPr anchor="ctr" marL="73152" marR="73152">
-                    <a:lnL w="9525">
-                      <a:solidFill>
-                        <a:srgbClr val="D3E2E0"/>
-                      </a:solidFill>
-                    </a:lnL>
-                    <a:lnR w="9525">
-                      <a:solidFill>
-                        <a:srgbClr val="D3E2E0"/>
-                      </a:solidFill>
-                    </a:lnR>
-                    <a:lnT w="9525">
-                      <a:solidFill>
-                        <a:srgbClr val="D3E2E0"/>
-                      </a:solidFill>
-                    </a:lnT>
-                    <a:lnB w="9525">
-                      <a:solidFill>
-                        <a:srgbClr val="D3E2E0"/>
-                      </a:solidFill>
-                    </a:lnB>
-                    <a:solidFill>
-                      <a:srgbClr val="FFFFFF"/>
-                    </a:solidFill>
-                  </a:tcPr>
-                </a:tc>
-                <a:tc>
-                  <a:txBody>
-                    <a:bodyPr wrap="square"/>
-                    <a:lstStyle/>
-                    <a:p>
-                      <a:pPr algn="l"/>
-                      <a:r>
-                        <a:rPr sz="1500" b="0">
-                          <a:solidFill>
-                            <a:srgbClr val="12262B"/>
-                          </a:solidFill>
-                        </a:rPr>
-                        <a:t>AI alone cheapest (1.61 vs 1.91 for either alarm)</a:t>
-                      </a:r>
-                    </a:p>
-                  </a:txBody>
-                  <a:tcPr anchor="ctr" marL="73152" marR="73152">
-                    <a:lnL w="9525">
-                      <a:solidFill>
-                        <a:srgbClr val="D3E2E0"/>
-                      </a:solidFill>
-                    </a:lnL>
-                    <a:lnR w="9525">
-                      <a:solidFill>
-                        <a:srgbClr val="D3E2E0"/>
-                      </a:solidFill>
-                    </a:lnR>
-                    <a:lnT w="9525">
-                      <a:solidFill>
-                        <a:srgbClr val="D3E2E0"/>
-                      </a:solidFill>
-                    </a:lnT>
-                    <a:lnB w="9525">
-                      <a:solidFill>
-                        <a:srgbClr val="D3E2E0"/>
-                      </a:solidFill>
-                    </a:lnB>
-                    <a:solidFill>
-                      <a:srgbClr val="FFFFFF"/>
-                    </a:solidFill>
-                  </a:tcPr>
-                </a:tc>
-              </a:tr>
-              <a:tr h="777240">
-                <a:tc>
-                  <a:txBody>
-                    <a:bodyPr wrap="square"/>
-                    <a:lstStyle/>
-                    <a:p>
-                      <a:pPr algn="l"/>
-                      <a:r>
-                        <a:rPr sz="1500" b="0">
-                          <a:solidFill>
-                            <a:srgbClr val="12262B"/>
-                          </a:solidFill>
-                        </a:rPr>
-                        <a:t>Set 1 B3 cross-talk from B4?</a:t>
-                      </a:r>
-                    </a:p>
-                  </a:txBody>
-                  <a:tcPr anchor="ctr" marL="73152" marR="73152">
-                    <a:lnL w="9525">
-                      <a:solidFill>
-                        <a:srgbClr val="D3E2E0"/>
-                      </a:solidFill>
-                    </a:lnL>
-                    <a:lnR w="9525">
-                      <a:solidFill>
-                        <a:srgbClr val="D3E2E0"/>
-                      </a:solidFill>
-                    </a:lnR>
-                    <a:lnT w="9525">
-                      <a:solidFill>
-                        <a:srgbClr val="D3E2E0"/>
-                      </a:solidFill>
-                    </a:lnT>
-                    <a:lnB w="9525">
-                      <a:solidFill>
-                        <a:srgbClr val="D3E2E0"/>
-                      </a:solidFill>
-                    </a:lnB>
-                    <a:solidFill>
-                      <a:srgbClr val="FFFFFF"/>
-                    </a:solidFill>
-                  </a:tcPr>
-                </a:tc>
-                <a:tc>
-                  <a:txBody>
-                    <a:bodyPr wrap="square"/>
-                    <a:lstStyle/>
-                    <a:p>
-                      <a:pPr algn="l"/>
-                      <a:r>
-                        <a:rPr sz="1500" b="0">
-                          <a:solidFill>
-                            <a:srgbClr val="12262B"/>
-                          </a:solidFill>
-                        </a:rPr>
-                        <a:t>Mostly no: B3's AI alarm is led by its own impacts (kurtosis, peak), not B4's roller rhythm</a:t>
-                      </a:r>
-                    </a:p>
-                  </a:txBody>
-                  <a:tcPr anchor="ctr" marL="73152" marR="73152">
-                    <a:lnL w="9525">
-                      <a:solidFill>
-                        <a:srgbClr val="D3E2E0"/>
-                      </a:solidFill>
-                    </a:lnL>
-                    <a:lnR w="9525">
-                      <a:solidFill>
-                        <a:srgbClr val="D3E2E0"/>
-                      </a:solidFill>
-                    </a:lnR>
-                    <a:lnT w="9525">
-                      <a:solidFill>
-                        <a:srgbClr val="D3E2E0"/>
-                      </a:solidFill>
-                    </a:lnT>
-                    <a:lnB w="9525">
-                      <a:solidFill>
-                        <a:srgbClr val="D3E2E0"/>
-                      </a:solidFill>
-                    </a:lnB>
-                    <a:solidFill>
-                      <a:srgbClr val="FFFFFF"/>
-                    </a:solidFill>
-                  </a:tcPr>
-                </a:tc>
-              </a:tr>
-            </a:tbl>
+          <a:graphicData uri="http://schemas.openxmlformats.org/drawingml/2006/chart">
+            <c:chart xmlns:c="http://schemas.openxmlformats.org/drawingml/2006/chart" r:id="rId3"/>
           </a:graphicData>
         </a:graphic>
       </p:graphicFrame>
       <p:sp>
         <p:nvSpPr>
-          <p:cNvPr id="27" name="stat 27 / 27"/>
+          <p:cNvPr id="27" name="stat ≤ 48 h"/>
           <p:cNvSpPr txBox="1"/>
           <p:nvPr/>
         </p:nvSpPr>
@@ -10711,10 +11322,10 @@
             <a:r>
               <a:rPr sz="4400" b="1">
                 <a:solidFill>
-                  <a:srgbClr val="3E9B5F"/>
+                  <a:srgbClr val="F26B4F"/>
                 </a:solidFill>
               </a:rPr>
-              <a:t>27 / 27</a:t>
+              <a:t>≤ 48 h</a:t>
             </a:r>
           </a:p>
         </p:txBody>
@@ -10752,14 +11363,14 @@
                   <a:srgbClr val="5E6E70"/>
                 </a:solidFill>
               </a:rPr>
-              <a:t>threshold settings where either alarm catches all 4</a:t>
-            </a:r>
-          </a:p>
-        </p:txBody>
-      </p:sp>
-      <p:sp>
-        <p:nvSpPr>
-          <p:cNvPr id="29" name="insurance note"/>
+              <a:t>lead time where acting on either alarm catches all 4</a:t>
+            </a:r>
+          </a:p>
+        </p:txBody>
+      </p:sp>
+      <p:sp>
+        <p:nvSpPr>
+          <p:cNvPr id="29" name="lead note"/>
           <p:cNvSpPr/>
           <p:nvPr/>
         </p:nvSpPr>
@@ -10836,7 +11447,7 @@
                   <a:srgbClr val="12262B"/>
                 </a:solidFill>
               </a:rPr>
-              <a:t>AI as insurance</a:t>
+              <a:t>At default thresholds</a:t>
             </a:r>
           </a:p>
           <a:p>
@@ -10851,7 +11462,7 @@
                   <a:srgbClr val="12262B"/>
                 </a:solidFill>
               </a:rPr>
-              <a:t>Physics alone needs a lucky threshold to catch all 4</a:t>
+              <a:t>≤ 8 h: physics alone is enough</a:t>
             </a:r>
           </a:p>
           <a:p>
@@ -10861,12 +11472,27 @@
               </a:spcAft>
             </a:pPr>
             <a:r>
-              <a:rPr sz="1500" b="1">
-                <a:solidFill>
-                  <a:srgbClr val="F26B4F"/>
+              <a:rPr sz="1500" b="0">
+                <a:solidFill>
+                  <a:srgbClr val="12262B"/>
                 </a:solidFill>
               </a:rPr>
-              <a:t>Either alarm catches all 4 in every setting tried</a:t>
+              <a:t>12-48 h: only physics OR AI catches all 4</a:t>
+            </a:r>
+          </a:p>
+          <a:p>
+            <a:pPr algn="l">
+              <a:spcAft>
+                <a:spcPts val="600"/>
+              </a:spcAft>
+            </a:pPr>
+            <a:r>
+              <a:rPr sz="1500" b="0">
+                <a:solidFill>
+                  <a:srgbClr val="12262B"/>
+                </a:solidFill>
+              </a:rPr>
+              <a:t>72 h: each rule catches only 1 of 4</a:t>
             </a:r>
           </a:p>
         </p:txBody>

</xml_diff>